<commit_message>
Add F&B schedule Gantt slide to field status report
Co-Authored-By: Claude Opus 5.5 <noreply@anthropic.com>
Claude-Session: https://claude.ai/code/session_01Vb9vKaZFq6SXomdoRU57mW
</commit_message>
<xml_diff>
--- a/社員会議資料/2026年9月_現場状況報告_神田.pptx
+++ b/社員会議資料/2026年9月_現場状況報告_神田.pptx
@@ -11,9 +11,10 @@
     <p:sldId id="259" r:id="rId5"/>
     <p:sldId id="260" r:id="rId6"/>
     <p:sldId id="261" r:id="rId7"/>
+    <p:sldId id="262" r:id="rId8"/>
   </p:sldIdLst>
   <p:notesMasterIdLst>
-    <p:notesMasterId r:id="rId8"/>
+    <p:notesMasterId r:id="rId9"/>
   </p:notesMasterIdLst>
   <p:sldSz cx="12192000" cy="6858000"/>
   <p:notesSz cx="6858000" cy="12192000"/>
@@ -112,19 +113,23 @@
   <p:extLst>
     <p:ext uri="{521415D9-36F7-43E2-AB2F-B90AF26B5E84}">
       <p14:sectionLst xmlns:p14="http://schemas.microsoft.com/office/powerpoint/2010/main">
-        <p14:section name="表紙" id="{46f86ead-1c53-b4a3-2d11-a5cc22769d9a}">
+        <p14:section name="表紙" id="{d630eb70-c253-d892-b9ce-ae1bb7c1431d}">
           <p14:sldIdLst>
             <p14:sldId id="256"/>
           </p14:sldIdLst>
         </p14:section>
-        <p14:section name="現場状況" id="{f13ba0b6-7491-2aae-90a5-ef96169a1726}">
+        <p14:section name="現場状況" id="{91546846-b52b-f770-42e7-0e0c6053183b}">
           <p14:sldIdLst>
             <p14:sldId id="257"/>
             <p14:sldId id="258"/>
             <p14:sldId id="259"/>
             <p14:sldId id="260"/>
             <p14:sldId id="261"/>
+            <p14:sldId id="262"/>
           </p14:sldIdLst>
+        </p14:section>
+        <p14:section name="飲食スケジュール" id="{4ae84f75-92ce-53bd-d127-173819f9f446}">
+          <p14:sldIdLst/>
         </p14:section>
       </p14:sectionLst>
     </p:ext>
@@ -994,6 +999,94 @@
             <a:fld id="{F7021451-1387-4CA6-816F-3879F97B5CBC}" type="slidenum">
               <a:rPr lang="en-US"/>
               <a:t>6</a:t>
+            </a:fld>
+            <a:endParaRPr lang="en-US"/>
+          </a:p>
+        </p:txBody>
+      </p:sp>
+    </p:spTree>
+    <p:extLst>
+      <p:ext uri="{BB962C8B-B14F-4D97-AF65-F5344CB8AC3E}">
+        <p14:creationId xmlns:p14="http://schemas.microsoft.com/office/powerpoint/2010/main" val="1024086991"/>
+      </p:ext>
+    </p:extLst>
+  </p:cSld>
+  <p:clrMapOvr>
+    <a:masterClrMapping/>
+  </p:clrMapOvr>
+</p:notes>
+</file>
+
+<file path=ppt/notesSlides/notesSlide7.xml><?xml version="1.0" encoding="utf-8"?>
+<p:notes xmlns:a="http://schemas.openxmlformats.org/drawingml/2006/main" xmlns:r="http://schemas.openxmlformats.org/officeDocument/2006/relationships" xmlns:p="http://schemas.openxmlformats.org/presentationml/2006/main">
+  <p:cSld>
+    <p:spTree>
+      <p:nvGrpSpPr>
+        <p:cNvPr id="1" name=""/>
+        <p:cNvGrpSpPr/>
+        <p:nvPr/>
+      </p:nvGrpSpPr>
+      <p:grpSpPr>
+        <a:xfrm>
+          <a:off x="0" y="0"/>
+          <a:ext cx="0" cy="0"/>
+          <a:chOff x="0" y="0"/>
+          <a:chExt cx="0" cy="0"/>
+        </a:xfrm>
+      </p:grpSpPr>
+      <p:sp>
+        <p:nvSpPr>
+          <p:cNvPr id="2" name="Slide Image Placeholder 1"/>
+          <p:cNvSpPr>
+            <a:spLocks noGrp="1" noRot="1" noChangeAspect="1"/>
+          </p:cNvSpPr>
+          <p:nvPr>
+            <p:ph type="sldImg"/>
+          </p:nvPr>
+        </p:nvSpPr>
+        <p:spPr/>
+      </p:sp>
+      <p:sp>
+        <p:nvSpPr>
+          <p:cNvPr id="3" name="Notes Placeholder 2"/>
+          <p:cNvSpPr>
+            <a:spLocks noGrp="1"/>
+          </p:cNvSpPr>
+          <p:nvPr>
+            <p:ph type="body" idx="1"/>
+          </p:nvPr>
+        </p:nvSpPr>
+        <p:spPr/>
+        <p:txBody>
+          <a:bodyPr/>
+          <a:lstStyle/>
+          <a:p>
+            <a:r>
+              <a:rPr lang="en-US" dirty="0"/>
+              <a:t>今後の飲食スケジュールです。10月下旬からビールセット、11月上旬から角煮カレーの販促強化。11月5日から麺やこころ、11月12日から12月8日までにじさんじ。11月中旬から冬の差込、11月下旬に健康促進を予定、12月中旬からGM価格改定です。</a:t>
+            </a:r>
+            <a:endParaRPr lang="en-US" dirty="0"/>
+          </a:p>
+        </p:txBody>
+      </p:sp>
+      <p:sp>
+        <p:nvSpPr>
+          <p:cNvPr id="4" name="Slide Number Placeholder 3"/>
+          <p:cNvSpPr>
+            <a:spLocks noGrp="1"/>
+          </p:cNvSpPr>
+          <p:nvPr>
+            <p:ph type="sldNum" sz="quarter" idx="10"/>
+          </p:nvPr>
+        </p:nvSpPr>
+        <p:spPr/>
+        <p:txBody>
+          <a:bodyPr/>
+          <a:lstStyle/>
+          <a:p>
+            <a:fld id="{F7021451-1387-4CA6-816F-3879F97B5CBC}" type="slidenum">
+              <a:rPr lang="en-US"/>
+              <a:t>7</a:t>
             </a:fld>
             <a:endParaRPr lang="en-US"/>
           </a:p>
@@ -2114,7 +2207,7 @@
         </p:nvSpPr>
         <p:spPr>
           <a:xfrm>
-            <a:off x="6400800" y="1600200"/>
+            <a:off x="6400800" y="1234440"/>
             <a:ext cx="731520" cy="548640"/>
           </a:xfrm>
           <a:prstGeom prst="rect">
@@ -2150,7 +2243,7 @@
         </p:nvSpPr>
         <p:spPr>
           <a:xfrm>
-            <a:off x="7223760" y="1554480"/>
+            <a:off x="7223760" y="1188720"/>
             <a:ext cx="4297680" cy="685800"/>
           </a:xfrm>
           <a:prstGeom prst="rect">
@@ -2200,7 +2293,7 @@
         </p:nvSpPr>
         <p:spPr>
           <a:xfrm>
-            <a:off x="6400800" y="2377440"/>
+            <a:off x="6400800" y="2011680"/>
             <a:ext cx="5120640" cy="0"/>
           </a:xfrm>
           <a:prstGeom prst="line">
@@ -2223,7 +2316,7 @@
         </p:nvSpPr>
         <p:spPr>
           <a:xfrm>
-            <a:off x="6400800" y="2560320"/>
+            <a:off x="6400800" y="2148840"/>
             <a:ext cx="731520" cy="548640"/>
           </a:xfrm>
           <a:prstGeom prst="rect">
@@ -2259,7 +2352,7 @@
         </p:nvSpPr>
         <p:spPr>
           <a:xfrm>
-            <a:off x="7223760" y="2514600"/>
+            <a:off x="7223760" y="2103120"/>
             <a:ext cx="4297680" cy="685800"/>
           </a:xfrm>
           <a:prstGeom prst="rect">
@@ -2309,7 +2402,7 @@
         </p:nvSpPr>
         <p:spPr>
           <a:xfrm>
-            <a:off x="6400800" y="3337560"/>
+            <a:off x="6400800" y="2926080"/>
             <a:ext cx="5120640" cy="0"/>
           </a:xfrm>
           <a:prstGeom prst="line">
@@ -2332,7 +2425,7 @@
         </p:nvSpPr>
         <p:spPr>
           <a:xfrm>
-            <a:off x="6400800" y="3520440"/>
+            <a:off x="6400800" y="3063240"/>
             <a:ext cx="731520" cy="548640"/>
           </a:xfrm>
           <a:prstGeom prst="rect">
@@ -2368,7 +2461,7 @@
         </p:nvSpPr>
         <p:spPr>
           <a:xfrm>
-            <a:off x="7223760" y="3474720"/>
+            <a:off x="7223760" y="3017520"/>
             <a:ext cx="4297680" cy="685800"/>
           </a:xfrm>
           <a:prstGeom prst="rect">
@@ -2418,7 +2511,7 @@
         </p:nvSpPr>
         <p:spPr>
           <a:xfrm>
-            <a:off x="6400800" y="4297680"/>
+            <a:off x="6400800" y="3840480"/>
             <a:ext cx="5120640" cy="0"/>
           </a:xfrm>
           <a:prstGeom prst="line">
@@ -2441,7 +2534,7 @@
         </p:nvSpPr>
         <p:spPr>
           <a:xfrm>
-            <a:off x="6400800" y="4480560"/>
+            <a:off x="6400800" y="3977640"/>
             <a:ext cx="731520" cy="548640"/>
           </a:xfrm>
           <a:prstGeom prst="rect">
@@ -2477,7 +2570,7 @@
         </p:nvSpPr>
         <p:spPr>
           <a:xfrm>
-            <a:off x="7223760" y="4434840"/>
+            <a:off x="7223760" y="3931920"/>
             <a:ext cx="4297680" cy="685800"/>
           </a:xfrm>
           <a:prstGeom prst="rect">
@@ -2514,6 +2607,115 @@
                 </a:solidFill>
               </a:rPr>
               <a:t>ゆで麺器・コンセント・蛇口</a:t>
+            </a:r>
+            <a:endParaRPr lang="en-US" sz="1800" dirty="0"/>
+          </a:p>
+        </p:txBody>
+      </p:sp>
+      <p:sp>
+        <p:nvSpPr>
+          <p:cNvPr id="17" name="rule-15"/>
+          <p:cNvSpPr/>
+          <p:nvPr/>
+        </p:nvSpPr>
+        <p:spPr>
+          <a:xfrm>
+            <a:off x="6400800" y="4754880"/>
+            <a:ext cx="5120640" cy="0"/>
+          </a:xfrm>
+          <a:prstGeom prst="line">
+            <a:avLst/>
+          </a:prstGeom>
+          <a:noFill/>
+          <a:ln w="9525">
+            <a:solidFill>
+              <a:schemeClr val="accent6"/>
+            </a:solidFill>
+            <a:prstDash val="solid"/>
+          </a:ln>
+        </p:spPr>
+      </p:sp>
+      <p:sp>
+        <p:nvSpPr>
+          <p:cNvPr id="18" name="t-16"/>
+          <p:cNvSpPr txBox="1"/>
+          <p:nvPr/>
+        </p:nvSpPr>
+        <p:spPr>
+          <a:xfrm>
+            <a:off x="6400800" y="4892040"/>
+            <a:ext cx="731520" cy="548640"/>
+          </a:xfrm>
+          <a:prstGeom prst="rect">
+            <a:avLst/>
+          </a:prstGeom>
+          <a:noFill/>
+          <a:ln/>
+        </p:spPr>
+        <p:txBody>
+          <a:bodyPr wrap="square" lIns="0" tIns="0" rIns="0" bIns="0" rtlCol="0" anchor="ctr"/>
+          <a:lstStyle/>
+          <a:p>
+            <a:pPr indent="0" marL="0">
+              <a:buNone/>
+            </a:pPr>
+            <a:r>
+              <a:rPr lang="en-US" sz="2400" b="1" dirty="0">
+                <a:solidFill>
+                  <a:schemeClr val="accent1"/>
+                </a:solidFill>
+              </a:rPr>
+              <a:t>05</a:t>
+            </a:r>
+            <a:endParaRPr lang="en-US" sz="2400" dirty="0"/>
+          </a:p>
+        </p:txBody>
+      </p:sp>
+      <p:sp>
+        <p:nvSpPr>
+          <p:cNvPr id="19" name="t-17"/>
+          <p:cNvSpPr txBox="1"/>
+          <p:nvPr/>
+        </p:nvSpPr>
+        <p:spPr>
+          <a:xfrm>
+            <a:off x="7223760" y="4846320"/>
+            <a:ext cx="4297680" cy="685800"/>
+          </a:xfrm>
+          <a:prstGeom prst="rect">
+            <a:avLst/>
+          </a:prstGeom>
+          <a:noFill/>
+          <a:ln/>
+        </p:spPr>
+        <p:txBody>
+          <a:bodyPr wrap="square" lIns="0" tIns="0" rIns="0" bIns="0" rtlCol="0" anchor="ctr"/>
+          <a:lstStyle/>
+          <a:p>
+            <a:pPr indent="0" marL="0">
+              <a:buNone/>
+            </a:pPr>
+            <a:r>
+              <a:rPr lang="en-US" sz="1800" b="1" dirty="0">
+                <a:solidFill>
+                  <a:schemeClr val="tx1"/>
+                </a:solidFill>
+              </a:rPr>
+              <a:t>飲食スケジュール</a:t>
+            </a:r>
+            <a:endParaRPr lang="en-US" sz="1800" dirty="0"/>
+          </a:p>
+          <a:p>
+            <a:pPr indent="0" marL="0">
+              <a:buNone/>
+            </a:pPr>
+            <a:r>
+              <a:rPr lang="en-US" sz="1200" dirty="0">
+                <a:solidFill>
+                  <a:schemeClr val="tx2"/>
+                </a:solidFill>
+              </a:rPr>
+              <a:t>10月下旬〜12月の企画・改定</a:t>
             </a:r>
             <a:endParaRPr lang="en-US" sz="1800" dirty="0"/>
           </a:p>
@@ -2731,7 +2933,7 @@
       </p:sp>
       <p:sp>
         <p:nvSpPr>
-          <p:cNvPr id="6" name="t-15"/>
+          <p:cNvPr id="6" name="t-18"/>
           <p:cNvSpPr txBox="1"/>
           <p:nvPr/>
         </p:nvSpPr>
@@ -2767,7 +2969,7 @@
       </p:sp>
       <p:sp>
         <p:nvSpPr>
-          <p:cNvPr id="7" name="t-16"/>
+          <p:cNvPr id="7" name="t-19"/>
           <p:cNvSpPr txBox="1"/>
           <p:nvPr/>
         </p:nvSpPr>
@@ -2803,7 +3005,7 @@
       </p:sp>
       <p:sp>
         <p:nvSpPr>
-          <p:cNvPr id="8" name="t-17"/>
+          <p:cNvPr id="8" name="t-20"/>
           <p:cNvSpPr txBox="1"/>
           <p:nvPr/>
         </p:nvSpPr>
@@ -2839,7 +3041,7 @@
       </p:sp>
       <p:sp>
         <p:nvSpPr>
-          <p:cNvPr id="9" name="row-bg-18"/>
+          <p:cNvPr id="9" name="row-bg-21"/>
           <p:cNvSpPr/>
           <p:nvPr/>
         </p:nvSpPr>
@@ -2864,7 +3066,7 @@
       </p:sp>
       <p:sp>
         <p:nvSpPr>
-          <p:cNvPr id="10" name="t-19"/>
+          <p:cNvPr id="10" name="t-22"/>
           <p:cNvSpPr txBox="1"/>
           <p:nvPr/>
         </p:nvSpPr>
@@ -2900,7 +3102,7 @@
       </p:sp>
       <p:sp>
         <p:nvSpPr>
-          <p:cNvPr id="11" name="t-20"/>
+          <p:cNvPr id="11" name="t-23"/>
           <p:cNvSpPr txBox="1"/>
           <p:nvPr/>
         </p:nvSpPr>
@@ -2936,7 +3138,7 @@
       </p:sp>
       <p:sp>
         <p:nvSpPr>
-          <p:cNvPr id="12" name="t-21"/>
+          <p:cNvPr id="12" name="t-24"/>
           <p:cNvSpPr txBox="1"/>
           <p:nvPr/>
         </p:nvSpPr>
@@ -2972,7 +3174,7 @@
       </p:sp>
       <p:sp>
         <p:nvSpPr>
-          <p:cNvPr id="13" name="prio-22"/>
+          <p:cNvPr id="13" name="prio-25"/>
           <p:cNvSpPr/>
           <p:nvPr/>
         </p:nvSpPr>
@@ -2997,7 +3199,7 @@
       </p:sp>
       <p:sp>
         <p:nvSpPr>
-          <p:cNvPr id="14" name="t-23"/>
+          <p:cNvPr id="14" name="t-26"/>
           <p:cNvSpPr txBox="1"/>
           <p:nvPr/>
         </p:nvSpPr>
@@ -3033,7 +3235,7 @@
       </p:sp>
       <p:sp>
         <p:nvSpPr>
-          <p:cNvPr id="15" name="row-bg-24"/>
+          <p:cNvPr id="15" name="row-bg-27"/>
           <p:cNvSpPr/>
           <p:nvPr/>
         </p:nvSpPr>
@@ -3058,7 +3260,7 @@
       </p:sp>
       <p:sp>
         <p:nvSpPr>
-          <p:cNvPr id="16" name="t-25"/>
+          <p:cNvPr id="16" name="t-28"/>
           <p:cNvSpPr txBox="1"/>
           <p:nvPr/>
         </p:nvSpPr>
@@ -3094,7 +3296,7 @@
       </p:sp>
       <p:sp>
         <p:nvSpPr>
-          <p:cNvPr id="17" name="t-26"/>
+          <p:cNvPr id="17" name="t-29"/>
           <p:cNvSpPr txBox="1"/>
           <p:nvPr/>
         </p:nvSpPr>
@@ -3130,7 +3332,7 @@
       </p:sp>
       <p:sp>
         <p:nvSpPr>
-          <p:cNvPr id="18" name="t-27"/>
+          <p:cNvPr id="18" name="t-30"/>
           <p:cNvSpPr txBox="1"/>
           <p:nvPr/>
         </p:nvSpPr>
@@ -3166,7 +3368,7 @@
       </p:sp>
       <p:sp>
         <p:nvSpPr>
-          <p:cNvPr id="19" name="prio-28"/>
+          <p:cNvPr id="19" name="prio-31"/>
           <p:cNvSpPr/>
           <p:nvPr/>
         </p:nvSpPr>
@@ -3191,7 +3393,7 @@
       </p:sp>
       <p:sp>
         <p:nvSpPr>
-          <p:cNvPr id="20" name="t-29"/>
+          <p:cNvPr id="20" name="t-32"/>
           <p:cNvSpPr txBox="1"/>
           <p:nvPr/>
         </p:nvSpPr>
@@ -3227,7 +3429,7 @@
       </p:sp>
       <p:sp>
         <p:nvSpPr>
-          <p:cNvPr id="21" name="row-bg-30"/>
+          <p:cNvPr id="21" name="row-bg-33"/>
           <p:cNvSpPr/>
           <p:nvPr/>
         </p:nvSpPr>
@@ -3252,7 +3454,7 @@
       </p:sp>
       <p:sp>
         <p:nvSpPr>
-          <p:cNvPr id="22" name="t-31"/>
+          <p:cNvPr id="22" name="t-34"/>
           <p:cNvSpPr txBox="1"/>
           <p:nvPr/>
         </p:nvSpPr>
@@ -3288,7 +3490,7 @@
       </p:sp>
       <p:sp>
         <p:nvSpPr>
-          <p:cNvPr id="23" name="t-32"/>
+          <p:cNvPr id="23" name="t-35"/>
           <p:cNvSpPr txBox="1"/>
           <p:nvPr/>
         </p:nvSpPr>
@@ -3324,7 +3526,7 @@
       </p:sp>
       <p:sp>
         <p:nvSpPr>
-          <p:cNvPr id="24" name="t-33"/>
+          <p:cNvPr id="24" name="t-36"/>
           <p:cNvSpPr txBox="1"/>
           <p:nvPr/>
         </p:nvSpPr>
@@ -3360,7 +3562,7 @@
       </p:sp>
       <p:sp>
         <p:nvSpPr>
-          <p:cNvPr id="25" name="prio-34"/>
+          <p:cNvPr id="25" name="prio-37"/>
           <p:cNvSpPr/>
           <p:nvPr/>
         </p:nvSpPr>
@@ -3385,7 +3587,7 @@
       </p:sp>
       <p:sp>
         <p:nvSpPr>
-          <p:cNvPr id="26" name="t-35"/>
+          <p:cNvPr id="26" name="t-38"/>
           <p:cNvSpPr txBox="1"/>
           <p:nvPr/>
         </p:nvSpPr>
@@ -3421,7 +3623,7 @@
       </p:sp>
       <p:sp>
         <p:nvSpPr>
-          <p:cNvPr id="27" name="row-bg-36"/>
+          <p:cNvPr id="27" name="row-bg-39"/>
           <p:cNvSpPr/>
           <p:nvPr/>
         </p:nvSpPr>
@@ -3446,7 +3648,7 @@
       </p:sp>
       <p:sp>
         <p:nvSpPr>
-          <p:cNvPr id="28" name="t-37"/>
+          <p:cNvPr id="28" name="t-40"/>
           <p:cNvSpPr txBox="1"/>
           <p:nvPr/>
         </p:nvSpPr>
@@ -3482,7 +3684,7 @@
       </p:sp>
       <p:sp>
         <p:nvSpPr>
-          <p:cNvPr id="29" name="t-38"/>
+          <p:cNvPr id="29" name="t-41"/>
           <p:cNvSpPr txBox="1"/>
           <p:nvPr/>
         </p:nvSpPr>
@@ -3518,7 +3720,7 @@
       </p:sp>
       <p:sp>
         <p:nvSpPr>
-          <p:cNvPr id="30" name="t-39"/>
+          <p:cNvPr id="30" name="t-42"/>
           <p:cNvSpPr txBox="1"/>
           <p:nvPr/>
         </p:nvSpPr>
@@ -3554,7 +3756,7 @@
       </p:sp>
       <p:sp>
         <p:nvSpPr>
-          <p:cNvPr id="31" name="prio-40"/>
+          <p:cNvPr id="31" name="prio-43"/>
           <p:cNvSpPr/>
           <p:nvPr/>
         </p:nvSpPr>
@@ -3579,7 +3781,7 @@
       </p:sp>
       <p:sp>
         <p:nvSpPr>
-          <p:cNvPr id="32" name="t-41"/>
+          <p:cNvPr id="32" name="t-44"/>
           <p:cNvSpPr txBox="1"/>
           <p:nvPr/>
         </p:nvSpPr>
@@ -3836,7 +4038,7 @@
       </p:sp>
       <p:sp>
         <p:nvSpPr>
-          <p:cNvPr id="6" name="t-42"/>
+          <p:cNvPr id="6" name="t-45"/>
           <p:cNvSpPr txBox="1"/>
           <p:nvPr/>
         </p:nvSpPr>
@@ -3872,7 +4074,7 @@
       </p:sp>
       <p:sp>
         <p:nvSpPr>
-          <p:cNvPr id="7" name="pat-bg-43"/>
+          <p:cNvPr id="7" name="pat-bg-46"/>
           <p:cNvSpPr/>
           <p:nvPr/>
         </p:nvSpPr>
@@ -3897,7 +4099,7 @@
       </p:sp>
       <p:sp>
         <p:nvSpPr>
-          <p:cNvPr id="8" name="t-44"/>
+          <p:cNvPr id="8" name="t-47"/>
           <p:cNvSpPr txBox="1"/>
           <p:nvPr/>
         </p:nvSpPr>
@@ -3961,7 +4163,7 @@
       </p:sp>
       <p:sp>
         <p:nvSpPr>
-          <p:cNvPr id="9" name="person-45"/>
+          <p:cNvPr id="9" name="person-48"/>
           <p:cNvSpPr/>
           <p:nvPr/>
         </p:nvSpPr>
@@ -3986,7 +4188,7 @@
       </p:sp>
       <p:sp>
         <p:nvSpPr>
-          <p:cNvPr id="10" name="t-46"/>
+          <p:cNvPr id="10" name="t-49"/>
           <p:cNvSpPr txBox="1"/>
           <p:nvPr/>
         </p:nvSpPr>
@@ -4036,7 +4238,7 @@
       </p:sp>
       <p:sp>
         <p:nvSpPr>
-          <p:cNvPr id="11" name="person-47"/>
+          <p:cNvPr id="11" name="person-50"/>
           <p:cNvSpPr/>
           <p:nvPr/>
         </p:nvSpPr>
@@ -4061,7 +4263,7 @@
       </p:sp>
       <p:sp>
         <p:nvSpPr>
-          <p:cNvPr id="12" name="t-48"/>
+          <p:cNvPr id="12" name="t-51"/>
           <p:cNvSpPr txBox="1"/>
           <p:nvPr/>
         </p:nvSpPr>
@@ -4111,7 +4313,7 @@
       </p:sp>
       <p:sp>
         <p:nvSpPr>
-          <p:cNvPr id="13" name="t-49"/>
+          <p:cNvPr id="13" name="t-52"/>
           <p:cNvSpPr txBox="1"/>
           <p:nvPr/>
         </p:nvSpPr>
@@ -4147,7 +4349,7 @@
       </p:sp>
       <p:sp>
         <p:nvSpPr>
-          <p:cNvPr id="14" name="pat-bg-50"/>
+          <p:cNvPr id="14" name="pat-bg-53"/>
           <p:cNvSpPr/>
           <p:nvPr/>
         </p:nvSpPr>
@@ -4172,7 +4374,7 @@
       </p:sp>
       <p:sp>
         <p:nvSpPr>
-          <p:cNvPr id="15" name="t-51"/>
+          <p:cNvPr id="15" name="t-54"/>
           <p:cNvSpPr txBox="1"/>
           <p:nvPr/>
         </p:nvSpPr>
@@ -4236,7 +4438,7 @@
       </p:sp>
       <p:sp>
         <p:nvSpPr>
-          <p:cNvPr id="16" name="person-52"/>
+          <p:cNvPr id="16" name="person-55"/>
           <p:cNvSpPr/>
           <p:nvPr/>
         </p:nvSpPr>
@@ -4261,7 +4463,7 @@
       </p:sp>
       <p:sp>
         <p:nvSpPr>
-          <p:cNvPr id="17" name="t-53"/>
+          <p:cNvPr id="17" name="t-56"/>
           <p:cNvSpPr txBox="1"/>
           <p:nvPr/>
         </p:nvSpPr>
@@ -4311,7 +4513,7 @@
       </p:sp>
       <p:sp>
         <p:nvSpPr>
-          <p:cNvPr id="18" name="person-54"/>
+          <p:cNvPr id="18" name="person-57"/>
           <p:cNvSpPr/>
           <p:nvPr/>
         </p:nvSpPr>
@@ -4336,7 +4538,7 @@
       </p:sp>
       <p:sp>
         <p:nvSpPr>
-          <p:cNvPr id="19" name="t-55"/>
+          <p:cNvPr id="19" name="t-58"/>
           <p:cNvSpPr txBox="1"/>
           <p:nvPr/>
         </p:nvSpPr>
@@ -4386,7 +4588,7 @@
       </p:sp>
       <p:sp>
         <p:nvSpPr>
-          <p:cNvPr id="20" name="person-56"/>
+          <p:cNvPr id="20" name="person-59"/>
           <p:cNvSpPr/>
           <p:nvPr/>
         </p:nvSpPr>
@@ -4411,7 +4613,7 @@
       </p:sp>
       <p:sp>
         <p:nvSpPr>
-          <p:cNvPr id="21" name="t-57"/>
+          <p:cNvPr id="21" name="t-60"/>
           <p:cNvSpPr txBox="1"/>
           <p:nvPr/>
         </p:nvSpPr>
@@ -4461,7 +4663,7 @@
       </p:sp>
       <p:sp>
         <p:nvSpPr>
-          <p:cNvPr id="22" name="t-58"/>
+          <p:cNvPr id="22" name="t-61"/>
           <p:cNvSpPr txBox="1"/>
           <p:nvPr/>
         </p:nvSpPr>
@@ -4497,7 +4699,7 @@
       </p:sp>
       <p:sp>
         <p:nvSpPr>
-          <p:cNvPr id="23" name="t-59"/>
+          <p:cNvPr id="23" name="t-62"/>
           <p:cNvSpPr txBox="1"/>
           <p:nvPr/>
         </p:nvSpPr>
@@ -4771,7 +4973,7 @@
       </p:sp>
       <p:sp>
         <p:nvSpPr>
-          <p:cNvPr id="6" name="t-60"/>
+          <p:cNvPr id="6" name="t-63"/>
           <p:cNvSpPr txBox="1"/>
           <p:nvPr/>
         </p:nvSpPr>
@@ -4807,7 +5009,7 @@
       </p:sp>
       <p:sp>
         <p:nvSpPr>
-          <p:cNvPr id="7" name="row-bg-61"/>
+          <p:cNvPr id="7" name="row-bg-64"/>
           <p:cNvSpPr/>
           <p:nvPr/>
         </p:nvSpPr>
@@ -4832,7 +5034,7 @@
       </p:sp>
       <p:sp>
         <p:nvSpPr>
-          <p:cNvPr id="8" name="t-62"/>
+          <p:cNvPr id="8" name="t-65"/>
           <p:cNvSpPr txBox="1"/>
           <p:nvPr/>
         </p:nvSpPr>
@@ -4868,7 +5070,7 @@
       </p:sp>
       <p:sp>
         <p:nvSpPr>
-          <p:cNvPr id="9" name="t-63"/>
+          <p:cNvPr id="9" name="t-66"/>
           <p:cNvSpPr txBox="1"/>
           <p:nvPr/>
         </p:nvSpPr>
@@ -4904,7 +5106,7 @@
       </p:sp>
       <p:sp>
         <p:nvSpPr>
-          <p:cNvPr id="10" name="t-64"/>
+          <p:cNvPr id="10" name="t-67"/>
           <p:cNvSpPr txBox="1"/>
           <p:nvPr/>
         </p:nvSpPr>
@@ -4940,7 +5142,7 @@
       </p:sp>
       <p:sp>
         <p:nvSpPr>
-          <p:cNvPr id="11" name="tag-bg-65"/>
+          <p:cNvPr id="11" name="tag-bg-68"/>
           <p:cNvSpPr/>
           <p:nvPr/>
         </p:nvSpPr>
@@ -4965,7 +5167,7 @@
       </p:sp>
       <p:sp>
         <p:nvSpPr>
-          <p:cNvPr id="12" name="t-66"/>
+          <p:cNvPr id="12" name="t-69"/>
           <p:cNvSpPr txBox="1"/>
           <p:nvPr/>
         </p:nvSpPr>
@@ -5001,7 +5203,7 @@
       </p:sp>
       <p:sp>
         <p:nvSpPr>
-          <p:cNvPr id="13" name="row-bg-67"/>
+          <p:cNvPr id="13" name="row-bg-70"/>
           <p:cNvSpPr/>
           <p:nvPr/>
         </p:nvSpPr>
@@ -5026,7 +5228,7 @@
       </p:sp>
       <p:sp>
         <p:nvSpPr>
-          <p:cNvPr id="14" name="t-68"/>
+          <p:cNvPr id="14" name="t-71"/>
           <p:cNvSpPr txBox="1"/>
           <p:nvPr/>
         </p:nvSpPr>
@@ -5062,7 +5264,7 @@
       </p:sp>
       <p:sp>
         <p:nvSpPr>
-          <p:cNvPr id="15" name="t-69"/>
+          <p:cNvPr id="15" name="t-72"/>
           <p:cNvSpPr txBox="1"/>
           <p:nvPr/>
         </p:nvSpPr>
@@ -5098,7 +5300,7 @@
       </p:sp>
       <p:sp>
         <p:nvSpPr>
-          <p:cNvPr id="16" name="t-70"/>
+          <p:cNvPr id="16" name="t-73"/>
           <p:cNvSpPr txBox="1"/>
           <p:nvPr/>
         </p:nvSpPr>
@@ -5134,7 +5336,7 @@
       </p:sp>
       <p:sp>
         <p:nvSpPr>
-          <p:cNvPr id="17" name="row-bg-71"/>
+          <p:cNvPr id="17" name="row-bg-74"/>
           <p:cNvSpPr/>
           <p:nvPr/>
         </p:nvSpPr>
@@ -5159,7 +5361,7 @@
       </p:sp>
       <p:sp>
         <p:nvSpPr>
-          <p:cNvPr id="18" name="t-72"/>
+          <p:cNvPr id="18" name="t-75"/>
           <p:cNvSpPr txBox="1"/>
           <p:nvPr/>
         </p:nvSpPr>
@@ -5195,7 +5397,7 @@
       </p:sp>
       <p:sp>
         <p:nvSpPr>
-          <p:cNvPr id="19" name="t-73"/>
+          <p:cNvPr id="19" name="t-76"/>
           <p:cNvSpPr txBox="1"/>
           <p:nvPr/>
         </p:nvSpPr>
@@ -5231,7 +5433,7 @@
       </p:sp>
       <p:sp>
         <p:nvSpPr>
-          <p:cNvPr id="20" name="t-74"/>
+          <p:cNvPr id="20" name="t-77"/>
           <p:cNvSpPr txBox="1"/>
           <p:nvPr/>
         </p:nvSpPr>
@@ -5522,7 +5724,7 @@
       </p:sp>
       <p:sp>
         <p:nvSpPr>
-          <p:cNvPr id="6" name="t-75"/>
+          <p:cNvPr id="6" name="t-78"/>
           <p:cNvSpPr txBox="1"/>
           <p:nvPr/>
         </p:nvSpPr>
@@ -5558,7 +5760,7 @@
       </p:sp>
       <p:sp>
         <p:nvSpPr>
-          <p:cNvPr id="7" name="row-bg-76"/>
+          <p:cNvPr id="7" name="row-bg-79"/>
           <p:cNvSpPr/>
           <p:nvPr/>
         </p:nvSpPr>
@@ -5583,7 +5785,7 @@
       </p:sp>
       <p:sp>
         <p:nvSpPr>
-          <p:cNvPr id="8" name="t-77"/>
+          <p:cNvPr id="8" name="t-80"/>
           <p:cNvSpPr txBox="1"/>
           <p:nvPr/>
         </p:nvSpPr>
@@ -5619,7 +5821,7 @@
       </p:sp>
       <p:sp>
         <p:nvSpPr>
-          <p:cNvPr id="9" name="t-78"/>
+          <p:cNvPr id="9" name="t-81"/>
           <p:cNvSpPr txBox="1"/>
           <p:nvPr/>
         </p:nvSpPr>
@@ -5655,7 +5857,7 @@
       </p:sp>
       <p:sp>
         <p:nvSpPr>
-          <p:cNvPr id="10" name="t-79"/>
+          <p:cNvPr id="10" name="t-82"/>
           <p:cNvSpPr txBox="1"/>
           <p:nvPr/>
         </p:nvSpPr>
@@ -5691,7 +5893,7 @@
       </p:sp>
       <p:sp>
         <p:nvSpPr>
-          <p:cNvPr id="11" name="row-bg-80"/>
+          <p:cNvPr id="11" name="row-bg-83"/>
           <p:cNvSpPr/>
           <p:nvPr/>
         </p:nvSpPr>
@@ -5716,7 +5918,7 @@
       </p:sp>
       <p:sp>
         <p:nvSpPr>
-          <p:cNvPr id="12" name="t-81"/>
+          <p:cNvPr id="12" name="t-84"/>
           <p:cNvSpPr txBox="1"/>
           <p:nvPr/>
         </p:nvSpPr>
@@ -5752,7 +5954,7 @@
       </p:sp>
       <p:sp>
         <p:nvSpPr>
-          <p:cNvPr id="13" name="t-82"/>
+          <p:cNvPr id="13" name="t-85"/>
           <p:cNvSpPr txBox="1"/>
           <p:nvPr/>
         </p:nvSpPr>
@@ -5788,7 +5990,7 @@
       </p:sp>
       <p:sp>
         <p:nvSpPr>
-          <p:cNvPr id="14" name="t-83"/>
+          <p:cNvPr id="14" name="t-86"/>
           <p:cNvSpPr txBox="1"/>
           <p:nvPr/>
         </p:nvSpPr>
@@ -5824,7 +6026,7 @@
       </p:sp>
       <p:sp>
         <p:nvSpPr>
-          <p:cNvPr id="15" name="row-bg-84"/>
+          <p:cNvPr id="15" name="row-bg-87"/>
           <p:cNvSpPr/>
           <p:nvPr/>
         </p:nvSpPr>
@@ -5849,7 +6051,7 @@
       </p:sp>
       <p:sp>
         <p:nvSpPr>
-          <p:cNvPr id="16" name="t-85"/>
+          <p:cNvPr id="16" name="t-88"/>
           <p:cNvSpPr txBox="1"/>
           <p:nvPr/>
         </p:nvSpPr>
@@ -5885,7 +6087,7 @@
       </p:sp>
       <p:sp>
         <p:nvSpPr>
-          <p:cNvPr id="17" name="t-86"/>
+          <p:cNvPr id="17" name="t-89"/>
           <p:cNvSpPr txBox="1"/>
           <p:nvPr/>
         </p:nvSpPr>
@@ -5921,7 +6123,7 @@
       </p:sp>
       <p:sp>
         <p:nvSpPr>
-          <p:cNvPr id="18" name="t-87"/>
+          <p:cNvPr id="18" name="t-90"/>
           <p:cNvSpPr txBox="1"/>
           <p:nvPr/>
         </p:nvSpPr>
@@ -6195,7 +6397,7 @@
       </p:sp>
       <p:sp>
         <p:nvSpPr>
-          <p:cNvPr id="6" name="t-88"/>
+          <p:cNvPr id="6" name="t-91"/>
           <p:cNvSpPr txBox="1"/>
           <p:nvPr/>
         </p:nvSpPr>
@@ -6231,7 +6433,7 @@
       </p:sp>
       <p:sp>
         <p:nvSpPr>
-          <p:cNvPr id="7" name="row-bg-89"/>
+          <p:cNvPr id="7" name="row-bg-92"/>
           <p:cNvSpPr/>
           <p:nvPr/>
         </p:nvSpPr>
@@ -6256,7 +6458,7 @@
       </p:sp>
       <p:sp>
         <p:nvSpPr>
-          <p:cNvPr id="8" name="t-90"/>
+          <p:cNvPr id="8" name="t-93"/>
           <p:cNvSpPr txBox="1"/>
           <p:nvPr/>
         </p:nvSpPr>
@@ -6292,7 +6494,7 @@
       </p:sp>
       <p:sp>
         <p:nvSpPr>
-          <p:cNvPr id="9" name="t-91"/>
+          <p:cNvPr id="9" name="t-94"/>
           <p:cNvSpPr txBox="1"/>
           <p:nvPr/>
         </p:nvSpPr>
@@ -6328,7 +6530,7 @@
       </p:sp>
       <p:sp>
         <p:nvSpPr>
-          <p:cNvPr id="10" name="t-92"/>
+          <p:cNvPr id="10" name="t-95"/>
           <p:cNvSpPr txBox="1"/>
           <p:nvPr/>
         </p:nvSpPr>
@@ -6364,7 +6566,7 @@
       </p:sp>
       <p:sp>
         <p:nvSpPr>
-          <p:cNvPr id="11" name="tag-bg-93"/>
+          <p:cNvPr id="11" name="tag-bg-96"/>
           <p:cNvSpPr/>
           <p:nvPr/>
         </p:nvSpPr>
@@ -6389,7 +6591,7 @@
       </p:sp>
       <p:sp>
         <p:nvSpPr>
-          <p:cNvPr id="12" name="t-94"/>
+          <p:cNvPr id="12" name="t-97"/>
           <p:cNvSpPr txBox="1"/>
           <p:nvPr/>
         </p:nvSpPr>
@@ -6425,7 +6627,7 @@
       </p:sp>
       <p:sp>
         <p:nvSpPr>
-          <p:cNvPr id="13" name="row-bg-95"/>
+          <p:cNvPr id="13" name="row-bg-98"/>
           <p:cNvSpPr/>
           <p:nvPr/>
         </p:nvSpPr>
@@ -6450,7 +6652,7 @@
       </p:sp>
       <p:sp>
         <p:nvSpPr>
-          <p:cNvPr id="14" name="t-96"/>
+          <p:cNvPr id="14" name="t-99"/>
           <p:cNvSpPr txBox="1"/>
           <p:nvPr/>
         </p:nvSpPr>
@@ -6486,7 +6688,7 @@
       </p:sp>
       <p:sp>
         <p:nvSpPr>
-          <p:cNvPr id="15" name="t-97"/>
+          <p:cNvPr id="15" name="t-100"/>
           <p:cNvSpPr txBox="1"/>
           <p:nvPr/>
         </p:nvSpPr>
@@ -6522,7 +6724,7 @@
       </p:sp>
       <p:sp>
         <p:nvSpPr>
-          <p:cNvPr id="16" name="t-98"/>
+          <p:cNvPr id="16" name="t-101"/>
           <p:cNvSpPr txBox="1"/>
           <p:nvPr/>
         </p:nvSpPr>
@@ -6558,7 +6760,7 @@
       </p:sp>
       <p:sp>
         <p:nvSpPr>
-          <p:cNvPr id="17" name="row-bg-99"/>
+          <p:cNvPr id="17" name="row-bg-102"/>
           <p:cNvSpPr/>
           <p:nvPr/>
         </p:nvSpPr>
@@ -6583,7 +6785,7 @@
       </p:sp>
       <p:sp>
         <p:nvSpPr>
-          <p:cNvPr id="18" name="t-100"/>
+          <p:cNvPr id="18" name="t-103"/>
           <p:cNvSpPr txBox="1"/>
           <p:nvPr/>
         </p:nvSpPr>
@@ -6619,7 +6821,7 @@
       </p:sp>
       <p:sp>
         <p:nvSpPr>
-          <p:cNvPr id="19" name="t-101"/>
+          <p:cNvPr id="19" name="t-104"/>
           <p:cNvSpPr txBox="1"/>
           <p:nvPr/>
         </p:nvSpPr>
@@ -6655,7 +6857,7 @@
       </p:sp>
       <p:sp>
         <p:nvSpPr>
-          <p:cNvPr id="20" name="t-102"/>
+          <p:cNvPr id="20" name="t-105"/>
           <p:cNvSpPr txBox="1"/>
           <p:nvPr/>
         </p:nvSpPr>
@@ -6729,6 +6931,1843 @@
             <a:fld id="{F7021451-1387-4CA6-816F-3879F97B5CBC}" type="slidenum">
               <a:rPr b="0" lang="en-US"/>
               <a:t>6</a:t>
+            </a:fld>
+            <a:endParaRPr lang="en-US"/>
+          </a:p>
+        </p:txBody>
+      </p:sp>
+    </p:spTree>
+  </p:cSld>
+  <p:clrMapOvr>
+    <a:masterClrMapping/>
+  </p:clrMapOvr>
+</p:sld>
+</file>
+
+<file path=ppt/slides/slide7.xml><?xml version="1.0" encoding="utf-8"?>
+<p:sld xmlns:a="http://schemas.openxmlformats.org/drawingml/2006/main" xmlns:r="http://schemas.openxmlformats.org/officeDocument/2006/relationships" xmlns:p="http://schemas.openxmlformats.org/presentationml/2006/main">
+  <p:cSld name="Slide 7">
+    <p:spTree>
+      <p:nvGrpSpPr>
+        <p:cNvPr id="1" name=""/>
+        <p:cNvGrpSpPr/>
+        <p:nvPr/>
+      </p:nvGrpSpPr>
+      <p:grpSpPr>
+        <a:xfrm>
+          <a:off x="0" y="0"/>
+          <a:ext cx="0" cy="0"/>
+          <a:chOff x="0" y="0"/>
+          <a:chExt cx="0" cy="0"/>
+        </a:xfrm>
+      </p:grpSpPr>
+      <p:sp>
+        <p:nvSpPr>
+          <p:cNvPr id="2" name="Text 1"/>
+          <p:cNvSpPr/>
+          <p:nvPr>
+            <p:ph idx="101" type="body" hasCustomPrompt="1"/>
+          </p:nvPr>
+        </p:nvSpPr>
+        <p:spPr>
+          <a:xfrm>
+            <a:off x="502920" y="685800"/>
+            <a:ext cx="2377440" cy="914400"/>
+          </a:xfrm>
+          <a:prstGeom prst="rect">
+            <a:avLst/>
+          </a:prstGeom>
+          <a:noFill/>
+          <a:ln/>
+        </p:spPr>
+        <p:txBody>
+          <a:bodyPr wrap="square" lIns="0" tIns="0" rIns="0" bIns="0" rtlCol="0" anchor="t"/>
+          <a:lstStyle/>
+          <a:p>
+            <a:pPr algn="l" indent="0" marL="0">
+              <a:buNone/>
+            </a:pPr>
+            <a:r>
+              <a:rPr lang="en-US" sz="5400" b="1" dirty="0">
+                <a:solidFill>
+                  <a:schemeClr val="accent4"/>
+                </a:solidFill>
+              </a:rPr>
+              <a:t>05</a:t>
+            </a:r>
+            <a:endParaRPr lang="en-US" sz="5400" dirty="0"/>
+          </a:p>
+        </p:txBody>
+      </p:sp>
+      <p:sp>
+        <p:nvSpPr>
+          <p:cNvPr id="3" name="Text 1"/>
+          <p:cNvSpPr/>
+          <p:nvPr>
+            <p:ph idx="102" type="title" hasCustomPrompt="1"/>
+          </p:nvPr>
+        </p:nvSpPr>
+        <p:spPr>
+          <a:xfrm>
+            <a:off x="502920" y="1691640"/>
+            <a:ext cx="2377440" cy="548640"/>
+          </a:xfrm>
+          <a:prstGeom prst="rect">
+            <a:avLst/>
+          </a:prstGeom>
+          <a:noFill/>
+          <a:ln/>
+        </p:spPr>
+        <p:txBody>
+          <a:bodyPr wrap="square" lIns="0" tIns="0" rIns="0" bIns="0" rtlCol="0" anchor="t"/>
+          <a:lstStyle/>
+          <a:p>
+            <a:pPr algn="l" indent="0" marL="0">
+              <a:buNone/>
+            </a:pPr>
+            <a:r>
+              <a:rPr lang="en-US" sz="2600" b="1" dirty="0">
+                <a:solidFill>
+                  <a:schemeClr val="bg1"/>
+                </a:solidFill>
+              </a:rPr>
+              <a:t>今後の予定</a:t>
+            </a:r>
+            <a:endParaRPr lang="en-US" sz="2600" dirty="0"/>
+          </a:p>
+        </p:txBody>
+      </p:sp>
+      <p:sp>
+        <p:nvSpPr>
+          <p:cNvPr id="4" name="Text 1"/>
+          <p:cNvSpPr/>
+          <p:nvPr>
+            <p:ph idx="103" type="body" hasCustomPrompt="1"/>
+          </p:nvPr>
+        </p:nvSpPr>
+        <p:spPr>
+          <a:xfrm>
+            <a:off x="502920" y="2514600"/>
+            <a:ext cx="2377440" cy="2377440"/>
+          </a:xfrm>
+          <a:prstGeom prst="rect">
+            <a:avLst/>
+          </a:prstGeom>
+          <a:noFill/>
+          <a:ln/>
+        </p:spPr>
+        <p:txBody>
+          <a:bodyPr wrap="square" lIns="0" tIns="0" rIns="0" bIns="0" rtlCol="0" anchor="t"/>
+          <a:lstStyle/>
+          <a:p>
+            <a:pPr algn="l" indent="0" marL="0">
+              <a:lnSpc>
+                <a:spcPct val="130000"/>
+              </a:lnSpc>
+              <a:buNone/>
+            </a:pPr>
+            <a:r>
+              <a:rPr lang="en-US" sz="1700" b="1" dirty="0">
+                <a:solidFill>
+                  <a:schemeClr val="bg1"/>
+                </a:solidFill>
+              </a:rPr>
+              <a:t>飲食スケジュール。</a:t>
+            </a:r>
+            <a:endParaRPr lang="en-US" sz="1700" dirty="0"/>
+          </a:p>
+          <a:p>
+            <a:pPr algn="l" indent="0" marL="0">
+              <a:lnSpc>
+                <a:spcPct val="130000"/>
+              </a:lnSpc>
+              <a:buNone/>
+            </a:pPr>
+            <a:r>
+              <a:rPr lang="en-US" sz="1700" b="1" dirty="0">
+                <a:solidFill>
+                  <a:schemeClr val="bg1"/>
+                </a:solidFill>
+              </a:rPr>
+              <a:t>11月は企画が集中。</a:t>
+            </a:r>
+            <a:endParaRPr lang="en-US" sz="1700" dirty="0"/>
+          </a:p>
+          <a:p>
+            <a:pPr algn="l" indent="0" marL="0">
+              <a:lnSpc>
+                <a:spcPct val="130000"/>
+              </a:lnSpc>
+              <a:buNone/>
+            </a:pPr>
+            <a:r>
+              <a:rPr lang="en-US" sz="1700" b="1" dirty="0">
+                <a:solidFill>
+                  <a:schemeClr val="bg1"/>
+                </a:solidFill>
+              </a:rPr>
+              <a:t>11/5 麺やこころ、</a:t>
+            </a:r>
+            <a:endParaRPr lang="en-US" sz="1700" dirty="0"/>
+          </a:p>
+          <a:p>
+            <a:pPr algn="l" indent="0" marL="0">
+              <a:lnSpc>
+                <a:spcPct val="130000"/>
+              </a:lnSpc>
+              <a:buNone/>
+            </a:pPr>
+            <a:r>
+              <a:rPr lang="en-US" sz="1700" b="1" dirty="0">
+                <a:solidFill>
+                  <a:schemeClr val="bg1"/>
+                </a:solidFill>
+              </a:rPr>
+              <a:t>11/12 にじさんじが</a:t>
+            </a:r>
+            <a:endParaRPr lang="en-US" sz="1700" dirty="0"/>
+          </a:p>
+          <a:p>
+            <a:pPr algn="l" indent="0" marL="0">
+              <a:lnSpc>
+                <a:spcPct val="130000"/>
+              </a:lnSpc>
+              <a:buNone/>
+            </a:pPr>
+            <a:r>
+              <a:rPr lang="en-US" sz="1700" b="1" dirty="0">
+                <a:solidFill>
+                  <a:schemeClr val="bg1"/>
+                </a:solidFill>
+              </a:rPr>
+              <a:t>スタート。</a:t>
+            </a:r>
+            <a:endParaRPr lang="en-US" sz="1700" dirty="0"/>
+          </a:p>
+        </p:txBody>
+      </p:sp>
+      <p:sp>
+        <p:nvSpPr>
+          <p:cNvPr id="6" name="month-bg-106"/>
+          <p:cNvSpPr/>
+          <p:nvPr/>
+        </p:nvSpPr>
+        <p:spPr>
+          <a:xfrm>
+            <a:off x="6053328" y="548640"/>
+            <a:ext cx="820204" cy="347472"/>
+          </a:xfrm>
+          <a:prstGeom prst="rect">
+            <a:avLst/>
+          </a:prstGeom>
+          <a:solidFill>
+            <a:schemeClr val="accent4"/>
+          </a:solidFill>
+          <a:ln w="12700">
+            <a:solidFill>
+              <a:schemeClr val="accent4"/>
+            </a:solidFill>
+            <a:prstDash val="solid"/>
+          </a:ln>
+        </p:spPr>
+      </p:sp>
+      <p:sp>
+        <p:nvSpPr>
+          <p:cNvPr id="7" name="t-107"/>
+          <p:cNvSpPr txBox="1"/>
+          <p:nvPr/>
+        </p:nvSpPr>
+        <p:spPr>
+          <a:xfrm>
+            <a:off x="6035040" y="548640"/>
+            <a:ext cx="856780" cy="347472"/>
+          </a:xfrm>
+          <a:prstGeom prst="rect">
+            <a:avLst/>
+          </a:prstGeom>
+          <a:noFill/>
+          <a:ln/>
+        </p:spPr>
+        <p:txBody>
+          <a:bodyPr wrap="square" lIns="0" tIns="0" rIns="0" bIns="0" rtlCol="0" anchor="ctr"/>
+          <a:lstStyle/>
+          <a:p>
+            <a:pPr algn="ctr" indent="0" marL="0">
+              <a:buNone/>
+            </a:pPr>
+            <a:r>
+              <a:rPr lang="en-US" sz="1300" b="1" dirty="0">
+                <a:solidFill>
+                  <a:schemeClr val="accent1"/>
+                </a:solidFill>
+              </a:rPr>
+              <a:t>10月</a:t>
+            </a:r>
+            <a:endParaRPr lang="en-US" sz="1300" dirty="0"/>
+          </a:p>
+        </p:txBody>
+      </p:sp>
+      <p:sp>
+        <p:nvSpPr>
+          <p:cNvPr id="8" name="month-bg-108"/>
+          <p:cNvSpPr/>
+          <p:nvPr/>
+        </p:nvSpPr>
+        <p:spPr>
+          <a:xfrm>
+            <a:off x="6910108" y="548640"/>
+            <a:ext cx="2300097" cy="347472"/>
+          </a:xfrm>
+          <a:prstGeom prst="rect">
+            <a:avLst/>
+          </a:prstGeom>
+          <a:solidFill>
+            <a:schemeClr val="accent1"/>
+          </a:solidFill>
+          <a:ln w="12700">
+            <a:solidFill>
+              <a:schemeClr val="accent1"/>
+            </a:solidFill>
+            <a:prstDash val="solid"/>
+          </a:ln>
+        </p:spPr>
+      </p:sp>
+      <p:sp>
+        <p:nvSpPr>
+          <p:cNvPr id="9" name="t-109"/>
+          <p:cNvSpPr txBox="1"/>
+          <p:nvPr/>
+        </p:nvSpPr>
+        <p:spPr>
+          <a:xfrm>
+            <a:off x="6891820" y="548640"/>
+            <a:ext cx="2336673" cy="347472"/>
+          </a:xfrm>
+          <a:prstGeom prst="rect">
+            <a:avLst/>
+          </a:prstGeom>
+          <a:noFill/>
+          <a:ln/>
+        </p:spPr>
+        <p:txBody>
+          <a:bodyPr wrap="square" lIns="0" tIns="0" rIns="0" bIns="0" rtlCol="0" anchor="ctr"/>
+          <a:lstStyle/>
+          <a:p>
+            <a:pPr algn="ctr" indent="0" marL="0">
+              <a:buNone/>
+            </a:pPr>
+            <a:r>
+              <a:rPr lang="en-US" sz="1300" b="1" dirty="0">
+                <a:solidFill>
+                  <a:schemeClr val="bg1"/>
+                </a:solidFill>
+              </a:rPr>
+              <a:t>11月</a:t>
+            </a:r>
+            <a:endParaRPr lang="en-US" sz="1300" dirty="0"/>
+          </a:p>
+        </p:txBody>
+      </p:sp>
+      <p:sp>
+        <p:nvSpPr>
+          <p:cNvPr id="10" name="month-bg-110"/>
+          <p:cNvSpPr/>
+          <p:nvPr/>
+        </p:nvSpPr>
+        <p:spPr>
+          <a:xfrm>
+            <a:off x="9246781" y="548640"/>
+            <a:ext cx="2377986" cy="347472"/>
+          </a:xfrm>
+          <a:prstGeom prst="rect">
+            <a:avLst/>
+          </a:prstGeom>
+          <a:solidFill>
+            <a:schemeClr val="accent4"/>
+          </a:solidFill>
+          <a:ln w="12700">
+            <a:solidFill>
+              <a:schemeClr val="accent4"/>
+            </a:solidFill>
+            <a:prstDash val="solid"/>
+          </a:ln>
+        </p:spPr>
+      </p:sp>
+      <p:sp>
+        <p:nvSpPr>
+          <p:cNvPr id="11" name="t-111"/>
+          <p:cNvSpPr txBox="1"/>
+          <p:nvPr/>
+        </p:nvSpPr>
+        <p:spPr>
+          <a:xfrm>
+            <a:off x="9228493" y="548640"/>
+            <a:ext cx="2414562" cy="347472"/>
+          </a:xfrm>
+          <a:prstGeom prst="rect">
+            <a:avLst/>
+          </a:prstGeom>
+          <a:noFill/>
+          <a:ln/>
+        </p:spPr>
+        <p:txBody>
+          <a:bodyPr wrap="square" lIns="0" tIns="0" rIns="0" bIns="0" rtlCol="0" anchor="ctr"/>
+          <a:lstStyle/>
+          <a:p>
+            <a:pPr algn="ctr" indent="0" marL="0">
+              <a:buNone/>
+            </a:pPr>
+            <a:r>
+              <a:rPr lang="en-US" sz="1300" b="1" dirty="0">
+                <a:solidFill>
+                  <a:schemeClr val="accent1"/>
+                </a:solidFill>
+              </a:rPr>
+              <a:t>12月</a:t>
+            </a:r>
+            <a:endParaRPr lang="en-US" sz="1300" dirty="0"/>
+          </a:p>
+        </p:txBody>
+      </p:sp>
+      <p:sp>
+        <p:nvSpPr>
+          <p:cNvPr id="12" name="t-112"/>
+          <p:cNvSpPr txBox="1"/>
+          <p:nvPr/>
+        </p:nvSpPr>
+        <p:spPr>
+          <a:xfrm>
+            <a:off x="6035040" y="941832"/>
+            <a:ext cx="856780" cy="274320"/>
+          </a:xfrm>
+          <a:prstGeom prst="rect">
+            <a:avLst/>
+          </a:prstGeom>
+          <a:noFill/>
+          <a:ln/>
+        </p:spPr>
+        <p:txBody>
+          <a:bodyPr wrap="square" lIns="0" tIns="0" rIns="0" bIns="0" rtlCol="0" anchor="ctr"/>
+          <a:lstStyle/>
+          <a:p>
+            <a:pPr algn="ctr" indent="0" marL="0">
+              <a:buNone/>
+            </a:pPr>
+            <a:r>
+              <a:rPr lang="en-US" sz="1000" dirty="0">
+                <a:solidFill>
+                  <a:schemeClr val="tx2"/>
+                </a:solidFill>
+              </a:rPr>
+              <a:t>下旬</a:t>
+            </a:r>
+            <a:endParaRPr lang="en-US" sz="1000" dirty="0"/>
+          </a:p>
+        </p:txBody>
+      </p:sp>
+      <p:sp>
+        <p:nvSpPr>
+          <p:cNvPr id="13" name="t-113"/>
+          <p:cNvSpPr txBox="1"/>
+          <p:nvPr/>
+        </p:nvSpPr>
+        <p:spPr>
+          <a:xfrm>
+            <a:off x="6891820" y="941832"/>
+            <a:ext cx="778891" cy="274320"/>
+          </a:xfrm>
+          <a:prstGeom prst="rect">
+            <a:avLst/>
+          </a:prstGeom>
+          <a:noFill/>
+          <a:ln/>
+        </p:spPr>
+        <p:txBody>
+          <a:bodyPr wrap="square" lIns="0" tIns="0" rIns="0" bIns="0" rtlCol="0" anchor="ctr"/>
+          <a:lstStyle/>
+          <a:p>
+            <a:pPr algn="ctr" indent="0" marL="0">
+              <a:buNone/>
+            </a:pPr>
+            <a:r>
+              <a:rPr lang="en-US" sz="1000" dirty="0">
+                <a:solidFill>
+                  <a:schemeClr val="tx2"/>
+                </a:solidFill>
+              </a:rPr>
+              <a:t>上旬</a:t>
+            </a:r>
+            <a:endParaRPr lang="en-US" sz="1000" dirty="0"/>
+          </a:p>
+        </p:txBody>
+      </p:sp>
+      <p:sp>
+        <p:nvSpPr>
+          <p:cNvPr id="14" name="t-114"/>
+          <p:cNvSpPr txBox="1"/>
+          <p:nvPr/>
+        </p:nvSpPr>
+        <p:spPr>
+          <a:xfrm>
+            <a:off x="7670711" y="941832"/>
+            <a:ext cx="778891" cy="274320"/>
+          </a:xfrm>
+          <a:prstGeom prst="rect">
+            <a:avLst/>
+          </a:prstGeom>
+          <a:noFill/>
+          <a:ln/>
+        </p:spPr>
+        <p:txBody>
+          <a:bodyPr wrap="square" lIns="0" tIns="0" rIns="0" bIns="0" rtlCol="0" anchor="ctr"/>
+          <a:lstStyle/>
+          <a:p>
+            <a:pPr algn="ctr" indent="0" marL="0">
+              <a:buNone/>
+            </a:pPr>
+            <a:r>
+              <a:rPr lang="en-US" sz="1000" dirty="0">
+                <a:solidFill>
+                  <a:schemeClr val="tx2"/>
+                </a:solidFill>
+              </a:rPr>
+              <a:t>中旬</a:t>
+            </a:r>
+            <a:endParaRPr lang="en-US" sz="1000" dirty="0"/>
+          </a:p>
+        </p:txBody>
+      </p:sp>
+      <p:sp>
+        <p:nvSpPr>
+          <p:cNvPr id="15" name="t-115"/>
+          <p:cNvSpPr txBox="1"/>
+          <p:nvPr/>
+        </p:nvSpPr>
+        <p:spPr>
+          <a:xfrm>
+            <a:off x="8449602" y="941832"/>
+            <a:ext cx="778891" cy="274320"/>
+          </a:xfrm>
+          <a:prstGeom prst="rect">
+            <a:avLst/>
+          </a:prstGeom>
+          <a:noFill/>
+          <a:ln/>
+        </p:spPr>
+        <p:txBody>
+          <a:bodyPr wrap="square" lIns="0" tIns="0" rIns="0" bIns="0" rtlCol="0" anchor="ctr"/>
+          <a:lstStyle/>
+          <a:p>
+            <a:pPr algn="ctr" indent="0" marL="0">
+              <a:buNone/>
+            </a:pPr>
+            <a:r>
+              <a:rPr lang="en-US" sz="1000" dirty="0">
+                <a:solidFill>
+                  <a:schemeClr val="tx2"/>
+                </a:solidFill>
+              </a:rPr>
+              <a:t>下旬</a:t>
+            </a:r>
+            <a:endParaRPr lang="en-US" sz="1000" dirty="0"/>
+          </a:p>
+        </p:txBody>
+      </p:sp>
+      <p:sp>
+        <p:nvSpPr>
+          <p:cNvPr id="16" name="t-116"/>
+          <p:cNvSpPr txBox="1"/>
+          <p:nvPr/>
+        </p:nvSpPr>
+        <p:spPr>
+          <a:xfrm>
+            <a:off x="9228493" y="941832"/>
+            <a:ext cx="778891" cy="274320"/>
+          </a:xfrm>
+          <a:prstGeom prst="rect">
+            <a:avLst/>
+          </a:prstGeom>
+          <a:noFill/>
+          <a:ln/>
+        </p:spPr>
+        <p:txBody>
+          <a:bodyPr wrap="square" lIns="0" tIns="0" rIns="0" bIns="0" rtlCol="0" anchor="ctr"/>
+          <a:lstStyle/>
+          <a:p>
+            <a:pPr algn="ctr" indent="0" marL="0">
+              <a:buNone/>
+            </a:pPr>
+            <a:r>
+              <a:rPr lang="en-US" sz="1000" dirty="0">
+                <a:solidFill>
+                  <a:schemeClr val="tx2"/>
+                </a:solidFill>
+              </a:rPr>
+              <a:t>上旬</a:t>
+            </a:r>
+            <a:endParaRPr lang="en-US" sz="1000" dirty="0"/>
+          </a:p>
+        </p:txBody>
+      </p:sp>
+      <p:sp>
+        <p:nvSpPr>
+          <p:cNvPr id="17" name="t-117"/>
+          <p:cNvSpPr txBox="1"/>
+          <p:nvPr/>
+        </p:nvSpPr>
+        <p:spPr>
+          <a:xfrm>
+            <a:off x="10007384" y="941832"/>
+            <a:ext cx="778891" cy="274320"/>
+          </a:xfrm>
+          <a:prstGeom prst="rect">
+            <a:avLst/>
+          </a:prstGeom>
+          <a:noFill/>
+          <a:ln/>
+        </p:spPr>
+        <p:txBody>
+          <a:bodyPr wrap="square" lIns="0" tIns="0" rIns="0" bIns="0" rtlCol="0" anchor="ctr"/>
+          <a:lstStyle/>
+          <a:p>
+            <a:pPr algn="ctr" indent="0" marL="0">
+              <a:buNone/>
+            </a:pPr>
+            <a:r>
+              <a:rPr lang="en-US" sz="1000" dirty="0">
+                <a:solidFill>
+                  <a:schemeClr val="tx2"/>
+                </a:solidFill>
+              </a:rPr>
+              <a:t>中旬</a:t>
+            </a:r>
+            <a:endParaRPr lang="en-US" sz="1000" dirty="0"/>
+          </a:p>
+        </p:txBody>
+      </p:sp>
+      <p:sp>
+        <p:nvSpPr>
+          <p:cNvPr id="18" name="t-118"/>
+          <p:cNvSpPr txBox="1"/>
+          <p:nvPr/>
+        </p:nvSpPr>
+        <p:spPr>
+          <a:xfrm>
+            <a:off x="10786275" y="941832"/>
+            <a:ext cx="856780" cy="274320"/>
+          </a:xfrm>
+          <a:prstGeom prst="rect">
+            <a:avLst/>
+          </a:prstGeom>
+          <a:noFill/>
+          <a:ln/>
+        </p:spPr>
+        <p:txBody>
+          <a:bodyPr wrap="square" lIns="0" tIns="0" rIns="0" bIns="0" rtlCol="0" anchor="ctr"/>
+          <a:lstStyle/>
+          <a:p>
+            <a:pPr algn="ctr" indent="0" marL="0">
+              <a:buNone/>
+            </a:pPr>
+            <a:r>
+              <a:rPr lang="en-US" sz="1000" dirty="0">
+                <a:solidFill>
+                  <a:schemeClr val="tx2"/>
+                </a:solidFill>
+              </a:rPr>
+              <a:t>下旬</a:t>
+            </a:r>
+            <a:endParaRPr lang="en-US" sz="1000" dirty="0"/>
+          </a:p>
+        </p:txBody>
+      </p:sp>
+      <p:sp>
+        <p:nvSpPr>
+          <p:cNvPr id="19" name="row-bg-119"/>
+          <p:cNvSpPr/>
+          <p:nvPr/>
+        </p:nvSpPr>
+        <p:spPr>
+          <a:xfrm>
+            <a:off x="3794760" y="1325880"/>
+            <a:ext cx="7848295" cy="658368"/>
+          </a:xfrm>
+          <a:prstGeom prst="rect">
+            <a:avLst/>
+          </a:prstGeom>
+          <a:solidFill>
+            <a:srgbClr val="F6F2EF"/>
+          </a:solidFill>
+          <a:ln w="12700">
+            <a:solidFill>
+              <a:srgbClr val="F6F2EF"/>
+            </a:solidFill>
+            <a:prstDash val="solid"/>
+          </a:ln>
+        </p:spPr>
+      </p:sp>
+      <p:sp>
+        <p:nvSpPr>
+          <p:cNvPr id="20" name="row-bg-120"/>
+          <p:cNvSpPr/>
+          <p:nvPr/>
+        </p:nvSpPr>
+        <p:spPr>
+          <a:xfrm>
+            <a:off x="3794760" y="2642616"/>
+            <a:ext cx="7848295" cy="658368"/>
+          </a:xfrm>
+          <a:prstGeom prst="rect">
+            <a:avLst/>
+          </a:prstGeom>
+          <a:solidFill>
+            <a:srgbClr val="F6F2EF"/>
+          </a:solidFill>
+          <a:ln w="12700">
+            <a:solidFill>
+              <a:srgbClr val="F6F2EF"/>
+            </a:solidFill>
+            <a:prstDash val="solid"/>
+          </a:ln>
+        </p:spPr>
+      </p:sp>
+      <p:sp>
+        <p:nvSpPr>
+          <p:cNvPr id="21" name="row-bg-121"/>
+          <p:cNvSpPr/>
+          <p:nvPr/>
+        </p:nvSpPr>
+        <p:spPr>
+          <a:xfrm>
+            <a:off x="3794760" y="3959352"/>
+            <a:ext cx="7848295" cy="658368"/>
+          </a:xfrm>
+          <a:prstGeom prst="rect">
+            <a:avLst/>
+          </a:prstGeom>
+          <a:solidFill>
+            <a:srgbClr val="F6F2EF"/>
+          </a:solidFill>
+          <a:ln w="12700">
+            <a:solidFill>
+              <a:srgbClr val="F6F2EF"/>
+            </a:solidFill>
+            <a:prstDash val="solid"/>
+          </a:ln>
+        </p:spPr>
+      </p:sp>
+      <p:sp>
+        <p:nvSpPr>
+          <p:cNvPr id="22" name="row-bg-122"/>
+          <p:cNvSpPr/>
+          <p:nvPr/>
+        </p:nvSpPr>
+        <p:spPr>
+          <a:xfrm>
+            <a:off x="3794760" y="5276088"/>
+            <a:ext cx="7848295" cy="658368"/>
+          </a:xfrm>
+          <a:prstGeom prst="rect">
+            <a:avLst/>
+          </a:prstGeom>
+          <a:solidFill>
+            <a:srgbClr val="F6F2EF"/>
+          </a:solidFill>
+          <a:ln w="12700">
+            <a:solidFill>
+              <a:srgbClr val="F6F2EF"/>
+            </a:solidFill>
+            <a:prstDash val="solid"/>
+          </a:ln>
+        </p:spPr>
+      </p:sp>
+      <p:sp>
+        <p:nvSpPr>
+          <p:cNvPr id="23" name="grid-123"/>
+          <p:cNvSpPr/>
+          <p:nvPr/>
+        </p:nvSpPr>
+        <p:spPr>
+          <a:xfrm>
+            <a:off x="6035040" y="1325880"/>
+            <a:ext cx="0" cy="4608576"/>
+          </a:xfrm>
+          <a:prstGeom prst="line">
+            <a:avLst/>
+          </a:prstGeom>
+          <a:noFill/>
+          <a:ln w="12700">
+            <a:solidFill>
+              <a:srgbClr val="9A918B"/>
+            </a:solidFill>
+            <a:prstDash val="solid"/>
+          </a:ln>
+        </p:spPr>
+      </p:sp>
+      <p:sp>
+        <p:nvSpPr>
+          <p:cNvPr id="24" name="grid-124"/>
+          <p:cNvSpPr/>
+          <p:nvPr/>
+        </p:nvSpPr>
+        <p:spPr>
+          <a:xfrm>
+            <a:off x="6891820" y="1325880"/>
+            <a:ext cx="0" cy="4608576"/>
+          </a:xfrm>
+          <a:prstGeom prst="line">
+            <a:avLst/>
+          </a:prstGeom>
+          <a:noFill/>
+          <a:ln w="12700">
+            <a:solidFill>
+              <a:srgbClr val="9A918B"/>
+            </a:solidFill>
+            <a:prstDash val="solid"/>
+          </a:ln>
+        </p:spPr>
+      </p:sp>
+      <p:sp>
+        <p:nvSpPr>
+          <p:cNvPr id="25" name="grid-125"/>
+          <p:cNvSpPr/>
+          <p:nvPr/>
+        </p:nvSpPr>
+        <p:spPr>
+          <a:xfrm>
+            <a:off x="7670711" y="1325880"/>
+            <a:ext cx="0" cy="4608576"/>
+          </a:xfrm>
+          <a:prstGeom prst="line">
+            <a:avLst/>
+          </a:prstGeom>
+          <a:noFill/>
+          <a:ln w="6350">
+            <a:solidFill>
+              <a:srgbClr val="E3DCD6"/>
+            </a:solidFill>
+            <a:prstDash val="dash"/>
+          </a:ln>
+        </p:spPr>
+      </p:sp>
+      <p:sp>
+        <p:nvSpPr>
+          <p:cNvPr id="26" name="grid-126"/>
+          <p:cNvSpPr/>
+          <p:nvPr/>
+        </p:nvSpPr>
+        <p:spPr>
+          <a:xfrm>
+            <a:off x="8449602" y="1325880"/>
+            <a:ext cx="0" cy="4608576"/>
+          </a:xfrm>
+          <a:prstGeom prst="line">
+            <a:avLst/>
+          </a:prstGeom>
+          <a:noFill/>
+          <a:ln w="6350">
+            <a:solidFill>
+              <a:srgbClr val="E3DCD6"/>
+            </a:solidFill>
+            <a:prstDash val="dash"/>
+          </a:ln>
+        </p:spPr>
+      </p:sp>
+      <p:sp>
+        <p:nvSpPr>
+          <p:cNvPr id="27" name="grid-127"/>
+          <p:cNvSpPr/>
+          <p:nvPr/>
+        </p:nvSpPr>
+        <p:spPr>
+          <a:xfrm>
+            <a:off x="9228493" y="1325880"/>
+            <a:ext cx="0" cy="4608576"/>
+          </a:xfrm>
+          <a:prstGeom prst="line">
+            <a:avLst/>
+          </a:prstGeom>
+          <a:noFill/>
+          <a:ln w="12700">
+            <a:solidFill>
+              <a:srgbClr val="9A918B"/>
+            </a:solidFill>
+            <a:prstDash val="solid"/>
+          </a:ln>
+        </p:spPr>
+      </p:sp>
+      <p:sp>
+        <p:nvSpPr>
+          <p:cNvPr id="28" name="grid-128"/>
+          <p:cNvSpPr/>
+          <p:nvPr/>
+        </p:nvSpPr>
+        <p:spPr>
+          <a:xfrm>
+            <a:off x="10007384" y="1325880"/>
+            <a:ext cx="0" cy="4608576"/>
+          </a:xfrm>
+          <a:prstGeom prst="line">
+            <a:avLst/>
+          </a:prstGeom>
+          <a:noFill/>
+          <a:ln w="6350">
+            <a:solidFill>
+              <a:srgbClr val="E3DCD6"/>
+            </a:solidFill>
+            <a:prstDash val="dash"/>
+          </a:ln>
+        </p:spPr>
+      </p:sp>
+      <p:sp>
+        <p:nvSpPr>
+          <p:cNvPr id="29" name="grid-129"/>
+          <p:cNvSpPr/>
+          <p:nvPr/>
+        </p:nvSpPr>
+        <p:spPr>
+          <a:xfrm>
+            <a:off x="10786275" y="1325880"/>
+            <a:ext cx="0" cy="4608576"/>
+          </a:xfrm>
+          <a:prstGeom prst="line">
+            <a:avLst/>
+          </a:prstGeom>
+          <a:noFill/>
+          <a:ln w="6350">
+            <a:solidFill>
+              <a:srgbClr val="E3DCD6"/>
+            </a:solidFill>
+            <a:prstDash val="dash"/>
+          </a:ln>
+        </p:spPr>
+      </p:sp>
+      <p:sp>
+        <p:nvSpPr>
+          <p:cNvPr id="30" name="grid-130"/>
+          <p:cNvSpPr/>
+          <p:nvPr/>
+        </p:nvSpPr>
+        <p:spPr>
+          <a:xfrm>
+            <a:off x="11643055" y="1325880"/>
+            <a:ext cx="0" cy="4608576"/>
+          </a:xfrm>
+          <a:prstGeom prst="line">
+            <a:avLst/>
+          </a:prstGeom>
+          <a:noFill/>
+          <a:ln w="12700">
+            <a:solidFill>
+              <a:srgbClr val="9A918B"/>
+            </a:solidFill>
+            <a:prstDash val="solid"/>
+          </a:ln>
+        </p:spPr>
+      </p:sp>
+      <p:sp>
+        <p:nvSpPr>
+          <p:cNvPr id="31" name="t-131"/>
+          <p:cNvSpPr txBox="1"/>
+          <p:nvPr/>
+        </p:nvSpPr>
+        <p:spPr>
+          <a:xfrm>
+            <a:off x="3977640" y="1325880"/>
+            <a:ext cx="1965960" cy="658368"/>
+          </a:xfrm>
+          <a:prstGeom prst="rect">
+            <a:avLst/>
+          </a:prstGeom>
+          <a:noFill/>
+          <a:ln/>
+        </p:spPr>
+        <p:txBody>
+          <a:bodyPr wrap="square" lIns="0" tIns="0" rIns="0" bIns="0" rtlCol="0" anchor="ctr"/>
+          <a:lstStyle/>
+          <a:p>
+            <a:pPr indent="0" marL="0">
+              <a:buNone/>
+            </a:pPr>
+            <a:r>
+              <a:rPr lang="en-US" sz="1400" b="1" dirty="0">
+                <a:solidFill>
+                  <a:schemeClr val="tx1"/>
+                </a:solidFill>
+              </a:rPr>
+              <a:t>ビールセット</a:t>
+            </a:r>
+            <a:endParaRPr lang="en-US" sz="1400" dirty="0"/>
+          </a:p>
+          <a:p>
+            <a:pPr indent="0" marL="0">
+              <a:buNone/>
+            </a:pPr>
+            <a:r>
+              <a:rPr lang="en-US" sz="1000" dirty="0">
+                <a:solidFill>
+                  <a:schemeClr val="tx2"/>
+                </a:solidFill>
+              </a:rPr>
+              <a:t>10月下旬〜11月初旬予定</a:t>
+            </a:r>
+            <a:endParaRPr lang="en-US" sz="1400" dirty="0"/>
+          </a:p>
+        </p:txBody>
+      </p:sp>
+      <p:sp>
+        <p:nvSpPr>
+          <p:cNvPr id="32" name="bar-132"/>
+          <p:cNvSpPr/>
+          <p:nvPr/>
+        </p:nvSpPr>
+        <p:spPr>
+          <a:xfrm>
+            <a:off x="6035040" y="1508760"/>
+            <a:ext cx="1168337" cy="292608"/>
+          </a:xfrm>
+          <a:prstGeom prst="rect">
+            <a:avLst/>
+          </a:prstGeom>
+          <a:solidFill>
+            <a:schemeClr val="bg1"/>
+          </a:solidFill>
+          <a:ln w="15875">
+            <a:solidFill>
+              <a:schemeClr val="accent1"/>
+            </a:solidFill>
+            <a:prstDash val="dash"/>
+          </a:ln>
+        </p:spPr>
+      </p:sp>
+      <p:sp>
+        <p:nvSpPr>
+          <p:cNvPr id="33" name="t-133"/>
+          <p:cNvSpPr txBox="1"/>
+          <p:nvPr/>
+        </p:nvSpPr>
+        <p:spPr>
+          <a:xfrm>
+            <a:off x="3977640" y="1984248"/>
+            <a:ext cx="1965960" cy="658368"/>
+          </a:xfrm>
+          <a:prstGeom prst="rect">
+            <a:avLst/>
+          </a:prstGeom>
+          <a:noFill/>
+          <a:ln/>
+        </p:spPr>
+        <p:txBody>
+          <a:bodyPr wrap="square" lIns="0" tIns="0" rIns="0" bIns="0" rtlCol="0" anchor="ctr"/>
+          <a:lstStyle/>
+          <a:p>
+            <a:pPr indent="0" marL="0">
+              <a:buNone/>
+            </a:pPr>
+            <a:r>
+              <a:rPr lang="en-US" sz="1400" b="1" dirty="0">
+                <a:solidFill>
+                  <a:schemeClr val="tx1"/>
+                </a:solidFill>
+              </a:rPr>
+              <a:t>角煮カレー販促強化</a:t>
+            </a:r>
+            <a:endParaRPr lang="en-US" sz="1400" dirty="0"/>
+          </a:p>
+          <a:p>
+            <a:pPr indent="0" marL="0">
+              <a:buNone/>
+            </a:pPr>
+            <a:r>
+              <a:rPr lang="en-US" sz="1000" dirty="0">
+                <a:solidFill>
+                  <a:schemeClr val="tx2"/>
+                </a:solidFill>
+              </a:rPr>
+              <a:t>11月上旬〜</a:t>
+            </a:r>
+            <a:endParaRPr lang="en-US" sz="1400" dirty="0"/>
+          </a:p>
+        </p:txBody>
+      </p:sp>
+      <p:sp>
+        <p:nvSpPr>
+          <p:cNvPr id="34" name="bar-134"/>
+          <p:cNvSpPr/>
+          <p:nvPr/>
+        </p:nvSpPr>
+        <p:spPr>
+          <a:xfrm>
+            <a:off x="6891820" y="2167128"/>
+            <a:ext cx="4751235" cy="292608"/>
+          </a:xfrm>
+          <a:prstGeom prst="rect">
+            <a:avLst/>
+          </a:prstGeom>
+          <a:solidFill>
+            <a:schemeClr val="accent1"/>
+          </a:solidFill>
+          <a:ln w="6350">
+            <a:solidFill>
+              <a:schemeClr val="accent1"/>
+            </a:solidFill>
+            <a:prstDash val="solid"/>
+          </a:ln>
+        </p:spPr>
+      </p:sp>
+      <p:sp>
+        <p:nvSpPr>
+          <p:cNvPr id="35" name="t-135"/>
+          <p:cNvSpPr txBox="1"/>
+          <p:nvPr/>
+        </p:nvSpPr>
+        <p:spPr>
+          <a:xfrm>
+            <a:off x="10820095" y="2167128"/>
+            <a:ext cx="749808" cy="292608"/>
+          </a:xfrm>
+          <a:prstGeom prst="rect">
+            <a:avLst/>
+          </a:prstGeom>
+          <a:noFill/>
+          <a:ln/>
+        </p:spPr>
+        <p:txBody>
+          <a:bodyPr wrap="square" lIns="0" tIns="0" rIns="0" bIns="0" rtlCol="0" anchor="ctr"/>
+          <a:lstStyle/>
+          <a:p>
+            <a:pPr algn="r" indent="0" marL="0">
+              <a:buNone/>
+            </a:pPr>
+            <a:r>
+              <a:rPr lang="en-US" sz="900" b="1" dirty="0">
+                <a:solidFill>
+                  <a:schemeClr val="bg1"/>
+                </a:solidFill>
+              </a:rPr>
+              <a:t>継続 →</a:t>
+            </a:r>
+            <a:endParaRPr lang="en-US" sz="900" dirty="0"/>
+          </a:p>
+        </p:txBody>
+      </p:sp>
+      <p:sp>
+        <p:nvSpPr>
+          <p:cNvPr id="36" name="t-136"/>
+          <p:cNvSpPr txBox="1"/>
+          <p:nvPr/>
+        </p:nvSpPr>
+        <p:spPr>
+          <a:xfrm>
+            <a:off x="3977640" y="2642616"/>
+            <a:ext cx="1965960" cy="658368"/>
+          </a:xfrm>
+          <a:prstGeom prst="rect">
+            <a:avLst/>
+          </a:prstGeom>
+          <a:noFill/>
+          <a:ln/>
+        </p:spPr>
+        <p:txBody>
+          <a:bodyPr wrap="square" lIns="0" tIns="0" rIns="0" bIns="0" rtlCol="0" anchor="ctr"/>
+          <a:lstStyle/>
+          <a:p>
+            <a:pPr indent="0" marL="0">
+              <a:buNone/>
+            </a:pPr>
+            <a:r>
+              <a:rPr lang="en-US" sz="1400" b="1" dirty="0">
+                <a:solidFill>
+                  <a:schemeClr val="tx1"/>
+                </a:solidFill>
+              </a:rPr>
+              <a:t>麺やこころ</a:t>
+            </a:r>
+            <a:endParaRPr lang="en-US" sz="1400" dirty="0"/>
+          </a:p>
+          <a:p>
+            <a:pPr indent="0" marL="0">
+              <a:buNone/>
+            </a:pPr>
+            <a:r>
+              <a:rPr lang="en-US" sz="1000" dirty="0">
+                <a:solidFill>
+                  <a:schemeClr val="tx2"/>
+                </a:solidFill>
+              </a:rPr>
+              <a:t>11/5〜</a:t>
+            </a:r>
+            <a:endParaRPr lang="en-US" sz="1400" dirty="0"/>
+          </a:p>
+        </p:txBody>
+      </p:sp>
+      <p:sp>
+        <p:nvSpPr>
+          <p:cNvPr id="37" name="bar-137"/>
+          <p:cNvSpPr/>
+          <p:nvPr/>
+        </p:nvSpPr>
+        <p:spPr>
+          <a:xfrm>
+            <a:off x="7203377" y="2825496"/>
+            <a:ext cx="4439679" cy="292608"/>
+          </a:xfrm>
+          <a:prstGeom prst="rect">
+            <a:avLst/>
+          </a:prstGeom>
+          <a:solidFill>
+            <a:schemeClr val="accent1"/>
+          </a:solidFill>
+          <a:ln w="6350">
+            <a:solidFill>
+              <a:schemeClr val="accent1"/>
+            </a:solidFill>
+            <a:prstDash val="solid"/>
+          </a:ln>
+        </p:spPr>
+      </p:sp>
+      <p:sp>
+        <p:nvSpPr>
+          <p:cNvPr id="38" name="t-138"/>
+          <p:cNvSpPr txBox="1"/>
+          <p:nvPr/>
+        </p:nvSpPr>
+        <p:spPr>
+          <a:xfrm>
+            <a:off x="10820095" y="2825496"/>
+            <a:ext cx="749808" cy="292608"/>
+          </a:xfrm>
+          <a:prstGeom prst="rect">
+            <a:avLst/>
+          </a:prstGeom>
+          <a:noFill/>
+          <a:ln/>
+        </p:spPr>
+        <p:txBody>
+          <a:bodyPr wrap="square" lIns="0" tIns="0" rIns="0" bIns="0" rtlCol="0" anchor="ctr"/>
+          <a:lstStyle/>
+          <a:p>
+            <a:pPr algn="r" indent="0" marL="0">
+              <a:buNone/>
+            </a:pPr>
+            <a:r>
+              <a:rPr lang="en-US" sz="900" b="1" dirty="0">
+                <a:solidFill>
+                  <a:schemeClr val="bg1"/>
+                </a:solidFill>
+              </a:rPr>
+              <a:t>継続 →</a:t>
+            </a:r>
+            <a:endParaRPr lang="en-US" sz="900" dirty="0"/>
+          </a:p>
+        </p:txBody>
+      </p:sp>
+      <p:sp>
+        <p:nvSpPr>
+          <p:cNvPr id="39" name="t-139"/>
+          <p:cNvSpPr txBox="1"/>
+          <p:nvPr/>
+        </p:nvSpPr>
+        <p:spPr>
+          <a:xfrm>
+            <a:off x="3977640" y="3300984"/>
+            <a:ext cx="1965960" cy="658368"/>
+          </a:xfrm>
+          <a:prstGeom prst="rect">
+            <a:avLst/>
+          </a:prstGeom>
+          <a:noFill/>
+          <a:ln/>
+        </p:spPr>
+        <p:txBody>
+          <a:bodyPr wrap="square" lIns="0" tIns="0" rIns="0" bIns="0" rtlCol="0" anchor="ctr"/>
+          <a:lstStyle/>
+          <a:p>
+            <a:pPr indent="0" marL="0">
+              <a:buNone/>
+            </a:pPr>
+            <a:r>
+              <a:rPr lang="en-US" sz="1400" b="1" dirty="0">
+                <a:solidFill>
+                  <a:schemeClr val="tx1"/>
+                </a:solidFill>
+              </a:rPr>
+              <a:t>にじさんじ</a:t>
+            </a:r>
+            <a:endParaRPr lang="en-US" sz="1400" dirty="0"/>
+          </a:p>
+          <a:p>
+            <a:pPr indent="0" marL="0">
+              <a:buNone/>
+            </a:pPr>
+            <a:r>
+              <a:rPr lang="en-US" sz="1000" dirty="0">
+                <a:solidFill>
+                  <a:schemeClr val="tx2"/>
+                </a:solidFill>
+              </a:rPr>
+              <a:t>11/12〜12/8</a:t>
+            </a:r>
+            <a:endParaRPr lang="en-US" sz="1400" dirty="0"/>
+          </a:p>
+        </p:txBody>
+      </p:sp>
+      <p:sp>
+        <p:nvSpPr>
+          <p:cNvPr id="40" name="bar-140"/>
+          <p:cNvSpPr/>
+          <p:nvPr/>
+        </p:nvSpPr>
+        <p:spPr>
+          <a:xfrm>
+            <a:off x="7748600" y="3483864"/>
+            <a:ext cx="2103006" cy="292608"/>
+          </a:xfrm>
+          <a:prstGeom prst="rect">
+            <a:avLst/>
+          </a:prstGeom>
+          <a:solidFill>
+            <a:schemeClr val="accent1"/>
+          </a:solidFill>
+          <a:ln w="6350">
+            <a:solidFill>
+              <a:schemeClr val="accent1"/>
+            </a:solidFill>
+            <a:prstDash val="solid"/>
+          </a:ln>
+        </p:spPr>
+      </p:sp>
+      <p:sp>
+        <p:nvSpPr>
+          <p:cNvPr id="41" name="t-141"/>
+          <p:cNvSpPr txBox="1"/>
+          <p:nvPr/>
+        </p:nvSpPr>
+        <p:spPr>
+          <a:xfrm>
+            <a:off x="7748600" y="3483864"/>
+            <a:ext cx="2103006" cy="292608"/>
+          </a:xfrm>
+          <a:prstGeom prst="rect">
+            <a:avLst/>
+          </a:prstGeom>
+          <a:noFill/>
+          <a:ln/>
+        </p:spPr>
+        <p:txBody>
+          <a:bodyPr wrap="square" lIns="0" tIns="0" rIns="0" bIns="0" rtlCol="0" anchor="ctr"/>
+          <a:lstStyle/>
+          <a:p>
+            <a:pPr algn="ctr" indent="0" marL="0">
+              <a:buNone/>
+            </a:pPr>
+            <a:r>
+              <a:rPr lang="en-US" sz="1000" b="1" dirty="0">
+                <a:solidFill>
+                  <a:schemeClr val="bg1"/>
+                </a:solidFill>
+              </a:rPr>
+              <a:t>11/12〜12/8</a:t>
+            </a:r>
+            <a:endParaRPr lang="en-US" sz="1000" dirty="0"/>
+          </a:p>
+        </p:txBody>
+      </p:sp>
+      <p:sp>
+        <p:nvSpPr>
+          <p:cNvPr id="42" name="t-142"/>
+          <p:cNvSpPr txBox="1"/>
+          <p:nvPr/>
+        </p:nvSpPr>
+        <p:spPr>
+          <a:xfrm>
+            <a:off x="3977640" y="3959352"/>
+            <a:ext cx="1965960" cy="658368"/>
+          </a:xfrm>
+          <a:prstGeom prst="rect">
+            <a:avLst/>
+          </a:prstGeom>
+          <a:noFill/>
+          <a:ln/>
+        </p:spPr>
+        <p:txBody>
+          <a:bodyPr wrap="square" lIns="0" tIns="0" rIns="0" bIns="0" rtlCol="0" anchor="ctr"/>
+          <a:lstStyle/>
+          <a:p>
+            <a:pPr indent="0" marL="0">
+              <a:buNone/>
+            </a:pPr>
+            <a:r>
+              <a:rPr lang="en-US" sz="1400" b="1" dirty="0">
+                <a:solidFill>
+                  <a:schemeClr val="tx1"/>
+                </a:solidFill>
+              </a:rPr>
+              <a:t>冬差込</a:t>
+            </a:r>
+            <a:endParaRPr lang="en-US" sz="1400" dirty="0"/>
+          </a:p>
+          <a:p>
+            <a:pPr indent="0" marL="0">
+              <a:buNone/>
+            </a:pPr>
+            <a:r>
+              <a:rPr lang="en-US" sz="1000" dirty="0">
+                <a:solidFill>
+                  <a:schemeClr val="tx2"/>
+                </a:solidFill>
+              </a:rPr>
+              <a:t>11月中旬〜</a:t>
+            </a:r>
+            <a:endParaRPr lang="en-US" sz="1400" dirty="0"/>
+          </a:p>
+        </p:txBody>
+      </p:sp>
+      <p:sp>
+        <p:nvSpPr>
+          <p:cNvPr id="43" name="bar-143"/>
+          <p:cNvSpPr/>
+          <p:nvPr/>
+        </p:nvSpPr>
+        <p:spPr>
+          <a:xfrm>
+            <a:off x="7670711" y="4142232"/>
+            <a:ext cx="3972344" cy="292608"/>
+          </a:xfrm>
+          <a:prstGeom prst="rect">
+            <a:avLst/>
+          </a:prstGeom>
+          <a:solidFill>
+            <a:schemeClr val="accent1"/>
+          </a:solidFill>
+          <a:ln w="6350">
+            <a:solidFill>
+              <a:schemeClr val="accent1"/>
+            </a:solidFill>
+            <a:prstDash val="solid"/>
+          </a:ln>
+        </p:spPr>
+      </p:sp>
+      <p:sp>
+        <p:nvSpPr>
+          <p:cNvPr id="44" name="t-144"/>
+          <p:cNvSpPr txBox="1"/>
+          <p:nvPr/>
+        </p:nvSpPr>
+        <p:spPr>
+          <a:xfrm>
+            <a:off x="10820095" y="4142232"/>
+            <a:ext cx="749808" cy="292608"/>
+          </a:xfrm>
+          <a:prstGeom prst="rect">
+            <a:avLst/>
+          </a:prstGeom>
+          <a:noFill/>
+          <a:ln/>
+        </p:spPr>
+        <p:txBody>
+          <a:bodyPr wrap="square" lIns="0" tIns="0" rIns="0" bIns="0" rtlCol="0" anchor="ctr"/>
+          <a:lstStyle/>
+          <a:p>
+            <a:pPr algn="r" indent="0" marL="0">
+              <a:buNone/>
+            </a:pPr>
+            <a:r>
+              <a:rPr lang="en-US" sz="900" b="1" dirty="0">
+                <a:solidFill>
+                  <a:schemeClr val="bg1"/>
+                </a:solidFill>
+              </a:rPr>
+              <a:t>継続 →</a:t>
+            </a:r>
+            <a:endParaRPr lang="en-US" sz="900" dirty="0"/>
+          </a:p>
+        </p:txBody>
+      </p:sp>
+      <p:sp>
+        <p:nvSpPr>
+          <p:cNvPr id="45" name="t-145"/>
+          <p:cNvSpPr txBox="1"/>
+          <p:nvPr/>
+        </p:nvSpPr>
+        <p:spPr>
+          <a:xfrm>
+            <a:off x="3977640" y="4617720"/>
+            <a:ext cx="1965960" cy="658368"/>
+          </a:xfrm>
+          <a:prstGeom prst="rect">
+            <a:avLst/>
+          </a:prstGeom>
+          <a:noFill/>
+          <a:ln/>
+        </p:spPr>
+        <p:txBody>
+          <a:bodyPr wrap="square" lIns="0" tIns="0" rIns="0" bIns="0" rtlCol="0" anchor="ctr"/>
+          <a:lstStyle/>
+          <a:p>
+            <a:pPr indent="0" marL="0">
+              <a:buNone/>
+            </a:pPr>
+            <a:r>
+              <a:rPr lang="en-US" sz="1400" b="1" dirty="0">
+                <a:solidFill>
+                  <a:schemeClr val="tx1"/>
+                </a:solidFill>
+              </a:rPr>
+              <a:t>健康促進</a:t>
+            </a:r>
+            <a:endParaRPr lang="en-US" sz="1400" dirty="0"/>
+          </a:p>
+          <a:p>
+            <a:pPr indent="0" marL="0">
+              <a:buNone/>
+            </a:pPr>
+            <a:r>
+              <a:rPr lang="en-US" sz="1000" dirty="0">
+                <a:solidFill>
+                  <a:schemeClr val="tx2"/>
+                </a:solidFill>
+              </a:rPr>
+              <a:t>11月下旬予定</a:t>
+            </a:r>
+            <a:endParaRPr lang="en-US" sz="1400" dirty="0"/>
+          </a:p>
+        </p:txBody>
+      </p:sp>
+      <p:sp>
+        <p:nvSpPr>
+          <p:cNvPr id="46" name="bar-146"/>
+          <p:cNvSpPr/>
+          <p:nvPr/>
+        </p:nvSpPr>
+        <p:spPr>
+          <a:xfrm>
+            <a:off x="8449602" y="4800600"/>
+            <a:ext cx="778891" cy="292608"/>
+          </a:xfrm>
+          <a:prstGeom prst="rect">
+            <a:avLst/>
+          </a:prstGeom>
+          <a:solidFill>
+            <a:schemeClr val="bg1"/>
+          </a:solidFill>
+          <a:ln w="15875">
+            <a:solidFill>
+              <a:schemeClr val="accent1"/>
+            </a:solidFill>
+            <a:prstDash val="dash"/>
+          </a:ln>
+        </p:spPr>
+      </p:sp>
+      <p:sp>
+        <p:nvSpPr>
+          <p:cNvPr id="47" name="t-147"/>
+          <p:cNvSpPr txBox="1"/>
+          <p:nvPr/>
+        </p:nvSpPr>
+        <p:spPr>
+          <a:xfrm>
+            <a:off x="3977640" y="5276088"/>
+            <a:ext cx="1965960" cy="658368"/>
+          </a:xfrm>
+          <a:prstGeom prst="rect">
+            <a:avLst/>
+          </a:prstGeom>
+          <a:noFill/>
+          <a:ln/>
+        </p:spPr>
+        <p:txBody>
+          <a:bodyPr wrap="square" lIns="0" tIns="0" rIns="0" bIns="0" rtlCol="0" anchor="ctr"/>
+          <a:lstStyle/>
+          <a:p>
+            <a:pPr indent="0" marL="0">
+              <a:buNone/>
+            </a:pPr>
+            <a:r>
+              <a:rPr lang="en-US" sz="1400" b="1" dirty="0">
+                <a:solidFill>
+                  <a:schemeClr val="tx1"/>
+                </a:solidFill>
+              </a:rPr>
+              <a:t>GM価格改定</a:t>
+            </a:r>
+            <a:endParaRPr lang="en-US" sz="1400" dirty="0"/>
+          </a:p>
+          <a:p>
+            <a:pPr indent="0" marL="0">
+              <a:buNone/>
+            </a:pPr>
+            <a:r>
+              <a:rPr lang="en-US" sz="1000" dirty="0">
+                <a:solidFill>
+                  <a:schemeClr val="tx2"/>
+                </a:solidFill>
+              </a:rPr>
+              <a:t>12月中旬〜</a:t>
+            </a:r>
+            <a:endParaRPr lang="en-US" sz="1400" dirty="0"/>
+          </a:p>
+        </p:txBody>
+      </p:sp>
+      <p:sp>
+        <p:nvSpPr>
+          <p:cNvPr id="48" name="bar-148"/>
+          <p:cNvSpPr/>
+          <p:nvPr/>
+        </p:nvSpPr>
+        <p:spPr>
+          <a:xfrm>
+            <a:off x="10007384" y="5458968"/>
+            <a:ext cx="1635671" cy="292608"/>
+          </a:xfrm>
+          <a:prstGeom prst="rect">
+            <a:avLst/>
+          </a:prstGeom>
+          <a:solidFill>
+            <a:schemeClr val="accent1"/>
+          </a:solidFill>
+          <a:ln w="6350">
+            <a:solidFill>
+              <a:schemeClr val="accent1"/>
+            </a:solidFill>
+            <a:prstDash val="solid"/>
+          </a:ln>
+        </p:spPr>
+      </p:sp>
+      <p:sp>
+        <p:nvSpPr>
+          <p:cNvPr id="49" name="t-149"/>
+          <p:cNvSpPr txBox="1"/>
+          <p:nvPr/>
+        </p:nvSpPr>
+        <p:spPr>
+          <a:xfrm>
+            <a:off x="10820095" y="5458968"/>
+            <a:ext cx="749808" cy="292608"/>
+          </a:xfrm>
+          <a:prstGeom prst="rect">
+            <a:avLst/>
+          </a:prstGeom>
+          <a:noFill/>
+          <a:ln/>
+        </p:spPr>
+        <p:txBody>
+          <a:bodyPr wrap="square" lIns="0" tIns="0" rIns="0" bIns="0" rtlCol="0" anchor="ctr"/>
+          <a:lstStyle/>
+          <a:p>
+            <a:pPr algn="r" indent="0" marL="0">
+              <a:buNone/>
+            </a:pPr>
+            <a:r>
+              <a:rPr lang="en-US" sz="900" b="1" dirty="0">
+                <a:solidFill>
+                  <a:schemeClr val="bg1"/>
+                </a:solidFill>
+              </a:rPr>
+              <a:t>継続 →</a:t>
+            </a:r>
+            <a:endParaRPr lang="en-US" sz="900" dirty="0"/>
+          </a:p>
+        </p:txBody>
+      </p:sp>
+      <p:sp>
+        <p:nvSpPr>
+          <p:cNvPr id="50" name="lg-fixed"/>
+          <p:cNvSpPr/>
+          <p:nvPr/>
+        </p:nvSpPr>
+        <p:spPr>
+          <a:xfrm>
+            <a:off x="3794760" y="6181344"/>
+            <a:ext cx="411480" cy="182880"/>
+          </a:xfrm>
+          <a:prstGeom prst="rect">
+            <a:avLst/>
+          </a:prstGeom>
+          <a:solidFill>
+            <a:schemeClr val="accent1"/>
+          </a:solidFill>
+          <a:ln w="12700">
+            <a:solidFill>
+              <a:schemeClr val="accent1"/>
+            </a:solidFill>
+            <a:prstDash val="solid"/>
+          </a:ln>
+        </p:spPr>
+      </p:sp>
+      <p:sp>
+        <p:nvSpPr>
+          <p:cNvPr id="51" name="t-150"/>
+          <p:cNvSpPr txBox="1"/>
+          <p:nvPr/>
+        </p:nvSpPr>
+        <p:spPr>
+          <a:xfrm>
+            <a:off x="4297680" y="6117336"/>
+            <a:ext cx="1097280" cy="310896"/>
+          </a:xfrm>
+          <a:prstGeom prst="rect">
+            <a:avLst/>
+          </a:prstGeom>
+          <a:noFill/>
+          <a:ln/>
+        </p:spPr>
+        <p:txBody>
+          <a:bodyPr wrap="square" lIns="0" tIns="0" rIns="0" bIns="0" rtlCol="0" anchor="ctr"/>
+          <a:lstStyle/>
+          <a:p>
+            <a:pPr indent="0" marL="0">
+              <a:buNone/>
+            </a:pPr>
+            <a:r>
+              <a:rPr lang="en-US" sz="1000" dirty="0">
+                <a:solidFill>
+                  <a:schemeClr val="tx2"/>
+                </a:solidFill>
+              </a:rPr>
+              <a:t>日程確定</a:t>
+            </a:r>
+            <a:endParaRPr lang="en-US" sz="1000" dirty="0"/>
+          </a:p>
+        </p:txBody>
+      </p:sp>
+      <p:sp>
+        <p:nvSpPr>
+          <p:cNvPr id="52" name="lg-plan"/>
+          <p:cNvSpPr/>
+          <p:nvPr/>
+        </p:nvSpPr>
+        <p:spPr>
+          <a:xfrm>
+            <a:off x="5394960" y="6181344"/>
+            <a:ext cx="411480" cy="182880"/>
+          </a:xfrm>
+          <a:prstGeom prst="rect">
+            <a:avLst/>
+          </a:prstGeom>
+          <a:solidFill>
+            <a:schemeClr val="bg1"/>
+          </a:solidFill>
+          <a:ln w="15875">
+            <a:solidFill>
+              <a:schemeClr val="accent1"/>
+            </a:solidFill>
+            <a:prstDash val="dash"/>
+          </a:ln>
+        </p:spPr>
+      </p:sp>
+      <p:sp>
+        <p:nvSpPr>
+          <p:cNvPr id="53" name="t-151"/>
+          <p:cNvSpPr txBox="1"/>
+          <p:nvPr/>
+        </p:nvSpPr>
+        <p:spPr>
+          <a:xfrm>
+            <a:off x="5897880" y="6117336"/>
+            <a:ext cx="1828800" cy="310896"/>
+          </a:xfrm>
+          <a:prstGeom prst="rect">
+            <a:avLst/>
+          </a:prstGeom>
+          <a:noFill/>
+          <a:ln/>
+        </p:spPr>
+        <p:txBody>
+          <a:bodyPr wrap="square" lIns="0" tIns="0" rIns="0" bIns="0" rtlCol="0" anchor="ctr"/>
+          <a:lstStyle/>
+          <a:p>
+            <a:pPr indent="0" marL="0">
+              <a:buNone/>
+            </a:pPr>
+            <a:r>
+              <a:rPr lang="en-US" sz="1000" dirty="0">
+                <a:solidFill>
+                  <a:schemeClr val="tx2"/>
+                </a:solidFill>
+              </a:rPr>
+              <a:t>予定（時期は目安）</a:t>
+            </a:r>
+            <a:endParaRPr lang="en-US" sz="1000" dirty="0"/>
+          </a:p>
+        </p:txBody>
+      </p:sp>
+      <p:sp>
+        <p:nvSpPr>
+          <p:cNvPr id="54" name="t-152"/>
+          <p:cNvSpPr txBox="1"/>
+          <p:nvPr/>
+        </p:nvSpPr>
+        <p:spPr>
+          <a:xfrm>
+            <a:off x="7726680" y="6117336"/>
+            <a:ext cx="2743200" cy="310896"/>
+          </a:xfrm>
+          <a:prstGeom prst="rect">
+            <a:avLst/>
+          </a:prstGeom>
+          <a:noFill/>
+          <a:ln/>
+        </p:spPr>
+        <p:txBody>
+          <a:bodyPr wrap="square" lIns="0" tIns="0" rIns="0" bIns="0" rtlCol="0" anchor="ctr"/>
+          <a:lstStyle/>
+          <a:p>
+            <a:pPr indent="0" marL="0">
+              <a:buNone/>
+            </a:pPr>
+            <a:r>
+              <a:rPr lang="en-US" sz="1000" dirty="0">
+                <a:solidFill>
+                  <a:schemeClr val="tx2"/>
+                </a:solidFill>
+              </a:rPr>
+              <a:t>「継続 →」は終了日未定</a:t>
+            </a:r>
+            <a:endParaRPr lang="en-US" sz="1000" dirty="0"/>
+          </a:p>
+        </p:txBody>
+      </p:sp>
+      <p:sp>
+        <p:nvSpPr>
+          <p:cNvPr id="25" name="Slide Number Placeholder 0"/>
+          <p:cNvSpPr>
+            <a:spLocks noGrp="1"/>
+          </p:cNvSpPr>
+          <p:nvPr>
+            <p:ph type="sldNum" sz="quarter" idx="4294967295"/>
+          </p:nvPr>
+        </p:nvSpPr>
+        <p:spPr>
+          <a:xfrm>
+            <a:off x="11094415" y="6400800"/>
+            <a:ext cx="548640" cy="228600"/>
+          </a:xfrm>
+          <a:prstGeom prst="rect">
+            <a:avLst/>
+          </a:prstGeom>
+          <a:extLst>
+            <a:ext uri="{C572A759-6A51-4108-AA02-DFA0A04FC94B}">
+              <ma14:wrappingTextBoxFlag xmlns:ma14="http://schemas.microsoft.com/office/mac/drawingml/2011/main" val="0"/>
+            </a:ext>
+          </a:extLst>
+        </p:spPr>
+        <p:txBody>
+          <a:bodyPr/>
+          <a:lstStyle>
+            <a:lvl1pPr>
+              <a:defRPr sz="900">
+                <a:solidFill>
+                  <a:schemeClr val="accent5"/>
+                </a:solidFill>
+              </a:defRPr>
+            </a:lvl1pPr>
+          </a:lstStyle>
+          <a:p>
+            <a:pPr algn="r"/>
+            <a:fld id="{F7021451-1387-4CA6-816F-3879F97B5CBC}" type="slidenum">
+              <a:rPr b="0" lang="en-US"/>
+              <a:t>7</a:t>
             </a:fld>
             <a:endParaRPr lang="en-US"/>
           </a:p>

</xml_diff>